<commit_message>
Added the correct transforms in tasks 6-10
</commit_message>
<xml_diff>
--- a/Deep learning for time-series/Assignment 2/Presentation.pptx
+++ b/Deep learning for time-series/Assignment 2/Presentation.pptx
@@ -7,17 +7,19 @@
   <p:sldIdLst>
     <p:sldId id="256" r:id="rId6"/>
     <p:sldId id="257" r:id="rId7"/>
-    <p:sldId id="258" r:id="rId13"/>
-    <p:sldId id="259" r:id="rId14"/>
-    <p:sldId id="260" r:id="rId15"/>
-    <p:sldId id="261" r:id="rId16"/>
-    <p:sldId id="262" r:id="rId17"/>
-    <p:sldId id="263" r:id="rId18"/>
+    <p:sldId id="262" r:id="rId8"/>
+    <p:sldId id="259" r:id="rId9"/>
+    <p:sldId id="265" r:id="rId10"/>
+    <p:sldId id="266" r:id="rId11"/>
+    <p:sldId id="267" r:id="rId12"/>
+    <p:sldId id="268" r:id="rId13"/>
+    <p:sldId id="269" r:id="rId14"/>
+    <p:sldId id="270" r:id="rId15"/>
   </p:sldIdLst>
   <p:sldSz cx="12192000" cy="6858000"/>
   <p:notesSz cx="6858000" cy="9144000"/>
   <p:custDataLst>
-    <p:tags r:id="rId8"/>
+    <p:tags r:id="rId16"/>
   </p:custDataLst>
   <p:defaultTextStyle>
     <a:defPPr>
@@ -272,7 +274,7 @@
           <a:p>
             <a:fld id="{1A886069-5185-423F-843D-C2F3A033B902}" type="datetimeFigureOut">
               <a:rPr lang="en-US" smtClean="0"/>
-              <a:t>4/22/2026</a:t>
+              <a:t>4/23/2026</a:t>
             </a:fld>
             <a:endParaRPr lang="en-US"/>
           </a:p>
@@ -326,7 +328,7 @@
           <a:p>
             <a:fld id="{80580A79-C1F5-4728-9713-FF2EEEBEE14A}" type="slidenum">
               <a:rPr lang="en-US" smtClean="0"/>
-              <a:t>‹nr.›</a:t>
+              <a:t>‹#›</a:t>
             </a:fld>
             <a:endParaRPr lang="en-US"/>
           </a:p>
@@ -471,7 +473,7 @@
           <a:p>
             <a:fld id="{1A886069-5185-423F-843D-C2F3A033B902}" type="datetimeFigureOut">
               <a:rPr lang="en-US" smtClean="0"/>
-              <a:t>4/22/2026</a:t>
+              <a:t>4/23/2026</a:t>
             </a:fld>
             <a:endParaRPr lang="en-US"/>
           </a:p>
@@ -525,7 +527,7 @@
           <a:p>
             <a:fld id="{80580A79-C1F5-4728-9713-FF2EEEBEE14A}" type="slidenum">
               <a:rPr lang="en-US" smtClean="0"/>
-              <a:t>‹nr.›</a:t>
+              <a:t>‹#›</a:t>
             </a:fld>
             <a:endParaRPr lang="en-US"/>
           </a:p>
@@ -680,7 +682,7 @@
           <a:p>
             <a:fld id="{1A886069-5185-423F-843D-C2F3A033B902}" type="datetimeFigureOut">
               <a:rPr lang="en-US" smtClean="0"/>
-              <a:t>4/22/2026</a:t>
+              <a:t>4/23/2026</a:t>
             </a:fld>
             <a:endParaRPr lang="en-US"/>
           </a:p>
@@ -734,7 +736,7 @@
           <a:p>
             <a:fld id="{80580A79-C1F5-4728-9713-FF2EEEBEE14A}" type="slidenum">
               <a:rPr lang="en-US" smtClean="0"/>
-              <a:t>‹nr.›</a:t>
+              <a:t>‹#›</a:t>
             </a:fld>
             <a:endParaRPr lang="en-US"/>
           </a:p>
@@ -879,7 +881,7 @@
           <a:p>
             <a:fld id="{1A886069-5185-423F-843D-C2F3A033B902}" type="datetimeFigureOut">
               <a:rPr lang="en-US" smtClean="0"/>
-              <a:t>4/22/2026</a:t>
+              <a:t>4/23/2026</a:t>
             </a:fld>
             <a:endParaRPr lang="en-US"/>
           </a:p>
@@ -933,7 +935,7 @@
           <a:p>
             <a:fld id="{80580A79-C1F5-4728-9713-FF2EEEBEE14A}" type="slidenum">
               <a:rPr lang="en-US" smtClean="0"/>
-              <a:t>‹nr.›</a:t>
+              <a:t>‹#›</a:t>
             </a:fld>
             <a:endParaRPr lang="en-US"/>
           </a:p>
@@ -1155,7 +1157,7 @@
           <a:p>
             <a:fld id="{1A886069-5185-423F-843D-C2F3A033B902}" type="datetimeFigureOut">
               <a:rPr lang="en-US" smtClean="0"/>
-              <a:t>4/22/2026</a:t>
+              <a:t>4/23/2026</a:t>
             </a:fld>
             <a:endParaRPr lang="en-US"/>
           </a:p>
@@ -1209,7 +1211,7 @@
           <a:p>
             <a:fld id="{80580A79-C1F5-4728-9713-FF2EEEBEE14A}" type="slidenum">
               <a:rPr lang="en-US" smtClean="0"/>
-              <a:t>‹nr.›</a:t>
+              <a:t>‹#›</a:t>
             </a:fld>
             <a:endParaRPr lang="en-US"/>
           </a:p>
@@ -1421,7 +1423,7 @@
           <a:p>
             <a:fld id="{1A886069-5185-423F-843D-C2F3A033B902}" type="datetimeFigureOut">
               <a:rPr lang="en-US" smtClean="0"/>
-              <a:t>4/22/2026</a:t>
+              <a:t>4/23/2026</a:t>
             </a:fld>
             <a:endParaRPr lang="en-US"/>
           </a:p>
@@ -1475,7 +1477,7 @@
           <a:p>
             <a:fld id="{80580A79-C1F5-4728-9713-FF2EEEBEE14A}" type="slidenum">
               <a:rPr lang="en-US" smtClean="0"/>
-              <a:t>‹nr.›</a:t>
+              <a:t>‹#›</a:t>
             </a:fld>
             <a:endParaRPr lang="en-US"/>
           </a:p>
@@ -1834,7 +1836,7 @@
           <a:p>
             <a:fld id="{1A886069-5185-423F-843D-C2F3A033B902}" type="datetimeFigureOut">
               <a:rPr lang="en-US" smtClean="0"/>
-              <a:t>4/22/2026</a:t>
+              <a:t>4/23/2026</a:t>
             </a:fld>
             <a:endParaRPr lang="en-US"/>
           </a:p>
@@ -1888,7 +1890,7 @@
           <a:p>
             <a:fld id="{80580A79-C1F5-4728-9713-FF2EEEBEE14A}" type="slidenum">
               <a:rPr lang="en-US" smtClean="0"/>
-              <a:t>‹nr.›</a:t>
+              <a:t>‹#›</a:t>
             </a:fld>
             <a:endParaRPr lang="en-US"/>
           </a:p>
@@ -1976,7 +1978,7 @@
           <a:p>
             <a:fld id="{1A886069-5185-423F-843D-C2F3A033B902}" type="datetimeFigureOut">
               <a:rPr lang="en-US" smtClean="0"/>
-              <a:t>4/22/2026</a:t>
+              <a:t>4/23/2026</a:t>
             </a:fld>
             <a:endParaRPr lang="en-US"/>
           </a:p>
@@ -2030,7 +2032,7 @@
           <a:p>
             <a:fld id="{80580A79-C1F5-4728-9713-FF2EEEBEE14A}" type="slidenum">
               <a:rPr lang="en-US" smtClean="0"/>
-              <a:t>‹nr.›</a:t>
+              <a:t>‹#›</a:t>
             </a:fld>
             <a:endParaRPr lang="en-US"/>
           </a:p>
@@ -2090,7 +2092,7 @@
           <a:p>
             <a:fld id="{1A886069-5185-423F-843D-C2F3A033B902}" type="datetimeFigureOut">
               <a:rPr lang="en-US" smtClean="0"/>
-              <a:t>4/22/2026</a:t>
+              <a:t>4/23/2026</a:t>
             </a:fld>
             <a:endParaRPr lang="en-US"/>
           </a:p>
@@ -2144,7 +2146,7 @@
           <a:p>
             <a:fld id="{80580A79-C1F5-4728-9713-FF2EEEBEE14A}" type="slidenum">
               <a:rPr lang="en-US" smtClean="0"/>
-              <a:t>‹nr.›</a:t>
+              <a:t>‹#›</a:t>
             </a:fld>
             <a:endParaRPr lang="en-US"/>
           </a:p>
@@ -2402,7 +2404,7 @@
           <a:p>
             <a:fld id="{1A886069-5185-423F-843D-C2F3A033B902}" type="datetimeFigureOut">
               <a:rPr lang="en-US" smtClean="0"/>
-              <a:t>4/22/2026</a:t>
+              <a:t>4/23/2026</a:t>
             </a:fld>
             <a:endParaRPr lang="en-US"/>
           </a:p>
@@ -2456,7 +2458,7 @@
           <a:p>
             <a:fld id="{80580A79-C1F5-4728-9713-FF2EEEBEE14A}" type="slidenum">
               <a:rPr lang="en-US" smtClean="0"/>
-              <a:t>‹nr.›</a:t>
+              <a:t>‹#›</a:t>
             </a:fld>
             <a:endParaRPr lang="en-US"/>
           </a:p>
@@ -2691,7 +2693,7 @@
           <a:p>
             <a:fld id="{1A886069-5185-423F-843D-C2F3A033B902}" type="datetimeFigureOut">
               <a:rPr lang="en-US" smtClean="0"/>
-              <a:t>4/22/2026</a:t>
+              <a:t>4/23/2026</a:t>
             </a:fld>
             <a:endParaRPr lang="en-US"/>
           </a:p>
@@ -2745,7 +2747,7 @@
           <a:p>
             <a:fld id="{80580A79-C1F5-4728-9713-FF2EEEBEE14A}" type="slidenum">
               <a:rPr lang="en-US" smtClean="0"/>
-              <a:t>‹nr.›</a:t>
+              <a:t>‹#›</a:t>
             </a:fld>
             <a:endParaRPr lang="en-US"/>
           </a:p>
@@ -2933,7 +2935,7 @@
           <a:p>
             <a:fld id="{1A886069-5185-423F-843D-C2F3A033B902}" type="datetimeFigureOut">
               <a:rPr lang="en-US" smtClean="0"/>
-              <a:t>4/22/2026</a:t>
+              <a:t>4/23/2026</a:t>
             </a:fld>
             <a:endParaRPr lang="en-US"/>
           </a:p>
@@ -3023,7 +3025,7 @@
           <a:p>
             <a:fld id="{80580A79-C1F5-4728-9713-FF2EEEBEE14A}" type="slidenum">
               <a:rPr lang="en-US" smtClean="0"/>
-              <a:t>‹nr.›</a:t>
+              <a:t>‹#›</a:t>
             </a:fld>
             <a:endParaRPr lang="en-US"/>
           </a:p>
@@ -3425,6 +3427,449 @@
 </p:sld>
 </file>
 
+<file path=ppt/slides/slide10.xml><?xml version="1.0" encoding="utf-8"?>
+<p:sld xmlns:a="http://schemas.openxmlformats.org/drawingml/2006/main" xmlns:r="http://schemas.openxmlformats.org/officeDocument/2006/relationships" xmlns:p="http://schemas.openxmlformats.org/presentationml/2006/main">
+  <p:cSld>
+    <p:spTree>
+      <p:nvGrpSpPr>
+        <p:cNvPr id="1" name=""/>
+        <p:cNvGrpSpPr/>
+        <p:nvPr/>
+      </p:nvGrpSpPr>
+      <p:grpSpPr>
+        <a:xfrm>
+          <a:off x="0" y="0"/>
+          <a:ext cx="0" cy="0"/>
+          <a:chOff x="0" y="0"/>
+          <a:chExt cx="0" cy="0"/>
+        </a:xfrm>
+      </p:grpSpPr>
+      <p:sp>
+        <p:nvSpPr>
+          <p:cNvPr id="10" name="HeaderBar"/>
+          <p:cNvSpPr>
+            <a:spLocks noGrp="1"/>
+          </p:cNvSpPr>
+          <p:nvPr/>
+        </p:nvSpPr>
+        <p:spPr>
+          <a:xfrm>
+            <a:off x="0" y="0"/>
+            <a:ext cx="12192000" cy="1050000"/>
+          </a:xfrm>
+          <a:prstGeom prst="rect">
+            <a:avLst/>
+          </a:prstGeom>
+          <a:solidFill>
+            <a:srgbClr val="1E2761"/>
+          </a:solidFill>
+          <a:ln>
+            <a:noFill/>
+          </a:ln>
+        </p:spPr>
+        <p:txBody>
+          <a:bodyPr/>
+          <a:lstStyle/>
+          <a:p>
+            <a:endParaRPr/>
+          </a:p>
+        </p:txBody>
+      </p:sp>
+      <p:sp>
+        <p:nvSpPr>
+          <p:cNvPr id="2" name="Title"/>
+          <p:cNvSpPr>
+            <a:spLocks noGrp="1"/>
+          </p:cNvSpPr>
+          <p:nvPr>
+            <p:ph type="title"/>
+          </p:nvPr>
+        </p:nvSpPr>
+        <p:spPr>
+          <a:xfrm>
+            <a:off x="457200" y="100000"/>
+            <a:ext cx="11277600" cy="850000"/>
+          </a:xfrm>
+        </p:spPr>
+        <p:txBody>
+          <a:bodyPr anchor="ctr"/>
+          <a:lstStyle/>
+          <a:p>
+            <a:r>
+              <a:rPr lang="en-US" sz="3200" b="1" dirty="0">
+                <a:solidFill>
+                  <a:srgbClr val="FFFFFF"/>
+                </a:solidFill>
+                <a:latin typeface="Calibri"/>
+              </a:rPr>
+              <a:t>Task 10 – Final Results &amp; Conclusions</a:t>
+            </a:r>
+          </a:p>
+        </p:txBody>
+      </p:sp>
+      <p:sp>
+        <p:nvSpPr>
+          <p:cNvPr id="3" name="LeftContent"/>
+          <p:cNvSpPr>
+            <a:spLocks noGrp="1"/>
+          </p:cNvSpPr>
+          <p:nvPr/>
+        </p:nvSpPr>
+        <p:spPr>
+          <a:xfrm>
+            <a:off x="457200" y="1200000"/>
+            <a:ext cx="3924300" cy="5200000"/>
+          </a:xfrm>
+          <a:prstGeom prst="rect">
+            <a:avLst/>
+          </a:prstGeom>
+          <a:noFill/>
+        </p:spPr>
+        <p:txBody>
+          <a:bodyPr>
+            <a:normAutofit/>
+          </a:bodyPr>
+          <a:lstStyle/>
+          <a:p>
+            <a:pPr>
+              <a:lnSpc>
+                <a:spcPts val="1400"/>
+              </a:lnSpc>
+              <a:spcBef>
+                <a:spcPts val="0"/>
+              </a:spcBef>
+            </a:pPr>
+            <a:r>
+              <a:rPr lang="en-US" sz="1800" b="1" dirty="0">
+                <a:solidFill>
+                  <a:srgbClr val="1E2761"/>
+                </a:solidFill>
+                <a:latin typeface="Calibri"/>
+              </a:rPr>
+              <a:t>Full Model Progression (test)</a:t>
+            </a:r>
+          </a:p>
+          <a:p>
+            <a:pPr>
+              <a:lnSpc>
+                <a:spcPts val="1300"/>
+              </a:lnSpc>
+              <a:spcBef>
+                <a:spcPts val="200"/>
+              </a:spcBef>
+            </a:pPr>
+            <a:r>
+              <a:rPr lang="en-US" sz="1400" b="1" dirty="0">
+                <a:latin typeface="Calibri"/>
+              </a:rPr>
+              <a:t>Seasonal naive baseline: </a:t>
+            </a:r>
+            <a:r>
+              <a:rPr lang="en-US" sz="1400" dirty="0">
+                <a:latin typeface="Calibri"/>
+              </a:rPr>
+              <a:t>MASE = 1.000 (reference)</a:t>
+            </a:r>
+          </a:p>
+          <a:p>
+            <a:pPr>
+              <a:lnSpc>
+                <a:spcPts val="1300"/>
+              </a:lnSpc>
+              <a:spcBef>
+                <a:spcPts val="200"/>
+              </a:spcBef>
+            </a:pPr>
+            <a:r>
+              <a:rPr lang="en-US" sz="1400" b="1" dirty="0">
+                <a:latin typeface="Calibri"/>
+              </a:rPr>
+              <a:t>Local model (Tasks 6): </a:t>
+            </a:r>
+            <a:r>
+              <a:rPr lang="en-US" sz="1400" dirty="0">
+                <a:latin typeface="Calibri"/>
+              </a:rPr>
+              <a:t>MASE: 0.568</a:t>
+            </a:r>
+          </a:p>
+          <a:p>
+            <a:pPr>
+              <a:lnSpc>
+                <a:spcPts val="1300"/>
+              </a:lnSpc>
+              <a:spcBef>
+                <a:spcPts val="200"/>
+              </a:spcBef>
+            </a:pPr>
+            <a:r>
+              <a:rPr lang="en-US" sz="1400" b="1" dirty="0">
+                <a:latin typeface="Calibri"/>
+              </a:rPr>
+              <a:t>Cohort model (Task 7):</a:t>
+            </a:r>
+            <a:r>
+              <a:rPr lang="en-US" sz="1400" dirty="0">
+                <a:latin typeface="Calibri"/>
+              </a:rPr>
+              <a:t> MASE: 0.711</a:t>
+            </a:r>
+          </a:p>
+          <a:p>
+            <a:pPr>
+              <a:lnSpc>
+                <a:spcPts val="1300"/>
+              </a:lnSpc>
+            </a:pPr>
+            <a:r>
+              <a:rPr lang="en-US" sz="1400" b="1" dirty="0">
+                <a:latin typeface="Calibri"/>
+              </a:rPr>
+              <a:t>Global model, no meta (Task 8): </a:t>
+            </a:r>
+            <a:r>
+              <a:rPr lang="en-US" sz="1400" dirty="0">
+                <a:latin typeface="Calibri"/>
+              </a:rPr>
+              <a:t>MASE 0.703</a:t>
+            </a:r>
+          </a:p>
+          <a:p>
+            <a:pPr>
+              <a:lnSpc>
+                <a:spcPts val="1300"/>
+              </a:lnSpc>
+            </a:pPr>
+            <a:r>
+              <a:rPr lang="en-US" sz="1400" b="1" dirty="0">
+                <a:latin typeface="Calibri"/>
+              </a:rPr>
+              <a:t>Global + count encoding (Task 9):</a:t>
+            </a:r>
+            <a:r>
+              <a:rPr lang="en-US" sz="1400" dirty="0">
+                <a:latin typeface="Calibri"/>
+              </a:rPr>
+              <a:t> MASE: 0.701</a:t>
+            </a:r>
+          </a:p>
+          <a:p>
+            <a:pPr>
+              <a:lnSpc>
+                <a:spcPts val="1300"/>
+              </a:lnSpc>
+            </a:pPr>
+            <a:r>
+              <a:rPr lang="en-US" sz="1400" b="1" dirty="0">
+                <a:latin typeface="Calibri"/>
+              </a:rPr>
+              <a:t>Tuned GFM — Grid: </a:t>
+            </a:r>
+            <a:r>
+              <a:rPr lang="en-US" sz="1400" dirty="0">
+                <a:latin typeface="Calibri"/>
+              </a:rPr>
+              <a:t>MASE = 0.566</a:t>
+            </a:r>
+          </a:p>
+          <a:p>
+            <a:pPr>
+              <a:lnSpc>
+                <a:spcPts val="1300"/>
+              </a:lnSpc>
+            </a:pPr>
+            <a:r>
+              <a:rPr lang="en-US" sz="1400" b="1" dirty="0">
+                <a:latin typeface="Calibri"/>
+              </a:rPr>
+              <a:t>Tuned GFM — Random: </a:t>
+            </a:r>
+            <a:r>
+              <a:rPr lang="en-US" sz="1400" dirty="0">
+                <a:latin typeface="Calibri"/>
+              </a:rPr>
+              <a:t>MASE = 0.565</a:t>
+            </a:r>
+          </a:p>
+          <a:p>
+            <a:pPr>
+              <a:lnSpc>
+                <a:spcPts val="1300"/>
+              </a:lnSpc>
+            </a:pPr>
+            <a:r>
+              <a:rPr lang="en-US" sz="1400" b="1" dirty="0">
+                <a:latin typeface="Calibri"/>
+              </a:rPr>
+              <a:t>Tuned GFM — Bayesian (Optuna): </a:t>
+            </a:r>
+            <a:r>
+              <a:rPr lang="en-US" sz="1400" b="1" dirty="0">
+                <a:solidFill>
+                  <a:srgbClr val="027A48"/>
+                </a:solidFill>
+                <a:latin typeface="Calibri"/>
+              </a:rPr>
+              <a:t>MASE = 0.561</a:t>
+            </a:r>
+          </a:p>
+        </p:txBody>
+      </p:sp>
+      <p:pic>
+        <p:nvPicPr>
+          <p:cNvPr id="7" name="Picture 6">
+            <a:extLst>
+              <a:ext uri="{FF2B5EF4-FFF2-40B4-BE49-F238E27FC236}">
+                <a16:creationId xmlns:a16="http://schemas.microsoft.com/office/drawing/2014/main" id="{B6D3DD0E-48E0-8E1B-4BCD-7DD8FCE24949}"/>
+              </a:ext>
+            </a:extLst>
+          </p:cNvPr>
+          <p:cNvPicPr>
+            <a:picLocks noChangeAspect="1"/>
+          </p:cNvPicPr>
+          <p:nvPr/>
+        </p:nvPicPr>
+        <p:blipFill>
+          <a:blip r:embed="rId2">
+            <a:extLst>
+              <a:ext uri="{28A0092B-C50C-407E-A947-70E740481C1C}">
+                <a14:useLocalDpi xmlns:a14="http://schemas.microsoft.com/office/drawing/2010/main" val="0"/>
+              </a:ext>
+            </a:extLst>
+          </a:blip>
+          <a:stretch>
+            <a:fillRect/>
+          </a:stretch>
+        </p:blipFill>
+        <p:spPr>
+          <a:xfrm>
+            <a:off x="899160" y="3211262"/>
+            <a:ext cx="9380220" cy="3309083"/>
+          </a:xfrm>
+          <a:prstGeom prst="rect">
+            <a:avLst/>
+          </a:prstGeom>
+        </p:spPr>
+      </p:pic>
+      <p:sp>
+        <p:nvSpPr>
+          <p:cNvPr id="8" name="LeftContent">
+            <a:extLst>
+              <a:ext uri="{FF2B5EF4-FFF2-40B4-BE49-F238E27FC236}">
+                <a16:creationId xmlns:a16="http://schemas.microsoft.com/office/drawing/2014/main" id="{4FBC65D4-7F61-6C91-3DCD-61FD50DCD808}"/>
+              </a:ext>
+            </a:extLst>
+          </p:cNvPr>
+          <p:cNvSpPr>
+            <a:spLocks noGrp="1"/>
+          </p:cNvSpPr>
+          <p:nvPr/>
+        </p:nvSpPr>
+        <p:spPr>
+          <a:xfrm>
+            <a:off x="5791200" y="1199999"/>
+            <a:ext cx="3924300" cy="5200000"/>
+          </a:xfrm>
+          <a:prstGeom prst="rect">
+            <a:avLst/>
+          </a:prstGeom>
+          <a:noFill/>
+        </p:spPr>
+        <p:txBody>
+          <a:bodyPr>
+            <a:normAutofit/>
+          </a:bodyPr>
+          <a:lstStyle/>
+          <a:p>
+            <a:pPr>
+              <a:lnSpc>
+                <a:spcPts val="1400"/>
+              </a:lnSpc>
+              <a:spcBef>
+                <a:spcPts val="500"/>
+              </a:spcBef>
+            </a:pPr>
+            <a:r>
+              <a:rPr lang="en-US" sz="1800" b="1" dirty="0">
+                <a:solidFill>
+                  <a:srgbClr val="1E2761"/>
+                </a:solidFill>
+                <a:latin typeface="Calibri"/>
+              </a:rPr>
+              <a:t>Key Takeaways</a:t>
+            </a:r>
+          </a:p>
+          <a:p>
+            <a:pPr>
+              <a:lnSpc>
+                <a:spcPts val="1300"/>
+              </a:lnSpc>
+              <a:spcBef>
+                <a:spcPts val="200"/>
+              </a:spcBef>
+            </a:pPr>
+            <a:r>
+              <a:rPr lang="en-US" sz="1400" dirty="0">
+                <a:latin typeface="Calibri"/>
+              </a:rPr>
+              <a:t>- Bayesian tuning delivers the best model</a:t>
+            </a:r>
+          </a:p>
+          <a:p>
+            <a:pPr>
+              <a:lnSpc>
+                <a:spcPts val="1300"/>
+              </a:lnSpc>
+              <a:spcBef>
+                <a:spcPts val="200"/>
+              </a:spcBef>
+            </a:pPr>
+            <a:r>
+              <a:rPr lang="en-US" sz="1400" dirty="0">
+                <a:latin typeface="Calibri"/>
+              </a:rPr>
+              <a:t>- Tuning matters more than local-vs-global choice: tuned GFM beats untuned local models (0.684 vs 0.721)</a:t>
+            </a:r>
+          </a:p>
+          <a:p>
+            <a:pPr>
+              <a:lnSpc>
+                <a:spcPts val="1300"/>
+              </a:lnSpc>
+              <a:spcBef>
+                <a:spcPts val="200"/>
+              </a:spcBef>
+            </a:pPr>
+            <a:endParaRPr lang="en-US" sz="1400" i="1" dirty="0">
+              <a:latin typeface="Calibri"/>
+            </a:endParaRPr>
+          </a:p>
+          <a:p>
+            <a:pPr>
+              <a:lnSpc>
+                <a:spcPts val="1300"/>
+              </a:lnSpc>
+              <a:spcBef>
+                <a:spcPts val="200"/>
+              </a:spcBef>
+            </a:pPr>
+            <a:r>
+              <a:rPr lang="en-US" sz="1400" i="1" dirty="0">
+                <a:latin typeface="Calibri"/>
+              </a:rPr>
+              <a:t>Final recommendation: a tuned global LightGBM with one hot encoded meta-features — scalable to all 5,566 households without per-household retraining.</a:t>
+            </a:r>
+          </a:p>
+        </p:txBody>
+      </p:sp>
+    </p:spTree>
+  </p:cSld>
+  <p:clrMapOvr>
+    <a:masterClrMapping/>
+  </p:clrMapOvr>
+</p:sld>
+</file>
+
 <file path=ppt/slides/slide2.xml><?xml version="1.0" encoding="utf-8"?>
 <p:sld xmlns:a="http://schemas.openxmlformats.org/drawingml/2006/main" xmlns:r="http://schemas.openxmlformats.org/officeDocument/2006/relationships" xmlns:p="http://schemas.openxmlformats.org/presentationml/2006/main">
   <p:cSld>
@@ -3444,13 +3889,38 @@
       </p:grpSpPr>
       <p:sp>
         <p:nvSpPr>
-          <p:cNvPr id="2" name="Titel 1">
-            <a:extLst>
-              <a:ext uri="{FF2B5EF4-FFF2-40B4-BE49-F238E27FC236}">
-                <a16:creationId xmlns:a16="http://schemas.microsoft.com/office/drawing/2014/main" id="{12A6182B-63C7-3DEA-D954-92113AB95BD6}"/>
-              </a:ext>
-            </a:extLst>
-          </p:cNvPr>
+          <p:cNvPr id="10" name="HeaderBar"/>
+          <p:cNvSpPr>
+            <a:spLocks noGrp="1"/>
+          </p:cNvSpPr>
+          <p:nvPr/>
+        </p:nvSpPr>
+        <p:spPr>
+          <a:xfrm>
+            <a:off x="0" y="0"/>
+            <a:ext cx="12192000" cy="1050000"/>
+          </a:xfrm>
+          <a:prstGeom prst="rect">
+            <a:avLst/>
+          </a:prstGeom>
+          <a:solidFill>
+            <a:srgbClr val="1E2761"/>
+          </a:solidFill>
+          <a:ln>
+            <a:noFill/>
+          </a:ln>
+        </p:spPr>
+        <p:txBody>
+          <a:bodyPr/>
+          <a:lstStyle/>
+          <a:p>
+            <a:endParaRPr/>
+          </a:p>
+        </p:txBody>
+      </p:sp>
+      <p:sp>
+        <p:nvSpPr>
+          <p:cNvPr id="2" name="Title"/>
           <p:cNvSpPr>
             <a:spLocks noGrp="1"/>
           </p:cNvSpPr>
@@ -3458,58 +3928,286 @@
             <p:ph type="title"/>
           </p:nvPr>
         </p:nvSpPr>
-        <p:spPr/>
+        <p:spPr>
+          <a:xfrm>
+            <a:off x="457200" y="100000"/>
+            <a:ext cx="11277600" cy="850000"/>
+          </a:xfrm>
+        </p:spPr>
+        <p:txBody>
+          <a:bodyPr anchor="ctr"/>
+          <a:lstStyle/>
+          <a:p>
+            <a:r>
+              <a:rPr lang="en-US" sz="3200" b="1" dirty="0">
+                <a:solidFill>
+                  <a:srgbClr val="FFFFFF"/>
+                </a:solidFill>
+                <a:latin typeface="Calibri"/>
+              </a:rPr>
+              <a:t>Task 02 – Missing Data &amp; Imputation</a:t>
+            </a:r>
+          </a:p>
+        </p:txBody>
+      </p:sp>
+      <p:sp>
+        <p:nvSpPr>
+          <p:cNvPr id="11" name="Divider"/>
+          <p:cNvSpPr>
+            <a:spLocks noGrp="1"/>
+          </p:cNvSpPr>
+          <p:nvPr/>
+        </p:nvSpPr>
+        <p:spPr>
+          <a:xfrm>
+            <a:off x="6096000" y="1200000"/>
+            <a:ext cx="50000" cy="5300000"/>
+          </a:xfrm>
+          <a:prstGeom prst="rect">
+            <a:avLst/>
+          </a:prstGeom>
+          <a:solidFill>
+            <a:srgbClr val="CADCFC"/>
+          </a:solidFill>
+          <a:ln>
+            <a:noFill/>
+          </a:ln>
+        </p:spPr>
         <p:txBody>
           <a:bodyPr/>
           <a:lstStyle/>
           <a:p>
-            <a:r>
-              <a:rPr lang="da-DK" dirty="0"/>
-              <a:t xml:space="preserve">Task 02 – Data </a:t>
-            </a:r>
-            <a:r>
-              <a:rPr lang="da-DK"/>
-              <a:t>imputation</a:t>
-            </a:r>
-          </a:p>
-        </p:txBody>
-      </p:sp>
-      <p:sp>
-        <p:nvSpPr>
-          <p:cNvPr id="3" name="Pladsholder til indhold 2">
-            <a:extLst>
-              <a:ext uri="{FF2B5EF4-FFF2-40B4-BE49-F238E27FC236}">
-                <a16:creationId xmlns:a16="http://schemas.microsoft.com/office/drawing/2014/main" id="{12E5962E-8CA7-8B04-F90C-3F26A29359B6}"/>
-              </a:ext>
-            </a:extLst>
-          </p:cNvPr>
-          <p:cNvSpPr>
-            <a:spLocks noGrp="1"/>
-          </p:cNvSpPr>
-          <p:nvPr>
-            <p:ph idx="1"/>
-          </p:nvPr>
-        </p:nvSpPr>
-        <p:spPr/>
-        <p:txBody>
-          <a:bodyPr/>
-          <a:lstStyle/>
-          <a:p>
-            <a:endParaRPr lang="da-DK"/>
-          </a:p>
-        </p:txBody>
-      </p:sp>
+            <a:endParaRPr/>
+          </a:p>
+        </p:txBody>
+      </p:sp>
+      <p:sp>
+        <p:nvSpPr>
+          <p:cNvPr id="4" name="RightColumn"/>
+          <p:cNvSpPr>
+            <a:spLocks noGrp="1"/>
+          </p:cNvSpPr>
+          <p:nvPr/>
+        </p:nvSpPr>
+        <p:spPr>
+          <a:xfrm>
+            <a:off x="237528" y="1220424"/>
+            <a:ext cx="5600000" cy="5300000"/>
+          </a:xfrm>
+          <a:prstGeom prst="rect">
+            <a:avLst/>
+          </a:prstGeom>
+          <a:noFill/>
+        </p:spPr>
+        <p:txBody>
+          <a:bodyPr>
+            <a:normAutofit/>
+          </a:bodyPr>
+          <a:lstStyle/>
+          <a:p>
+            <a:pPr>
+              <a:lnSpc>
+                <a:spcPts val="1400"/>
+              </a:lnSpc>
+              <a:spcBef>
+                <a:spcPts val="0"/>
+              </a:spcBef>
+            </a:pPr>
+            <a:r>
+              <a:rPr lang="en-US" sz="1800" b="1" dirty="0">
+                <a:solidFill>
+                  <a:srgbClr val="1E2761"/>
+                </a:solidFill>
+                <a:latin typeface="Calibri"/>
+              </a:rPr>
+              <a:t>House quality filter</a:t>
+            </a:r>
+          </a:p>
+          <a:p>
+            <a:pPr>
+              <a:lnSpc>
+                <a:spcPts val="1400"/>
+              </a:lnSpc>
+            </a:pPr>
+            <a:r>
+              <a:rPr lang="en-US" sz="1400" dirty="0">
+                <a:latin typeface="Calibri"/>
+              </a:rPr>
+              <a:t>Drop household if either</a:t>
+            </a:r>
+            <a:br>
+              <a:rPr lang="en-US" sz="1400" dirty="0">
+                <a:latin typeface="Calibri"/>
+              </a:rPr>
+            </a:br>
+            <a:r>
+              <a:rPr lang="en-US" sz="1400" dirty="0">
+                <a:latin typeface="Calibri"/>
+              </a:rPr>
+              <a:t>- more than 10% of values are missing</a:t>
+            </a:r>
+            <a:br>
+              <a:rPr lang="en-US" sz="1400" dirty="0">
+                <a:latin typeface="Calibri"/>
+              </a:rPr>
+            </a:br>
+            <a:r>
+              <a:rPr lang="en-US" sz="1400" dirty="0">
+                <a:latin typeface="Calibri"/>
+              </a:rPr>
+              <a:t>- a gap is longer than 48 hours (aggressive)</a:t>
+            </a:r>
+            <a:endParaRPr lang="en-US" sz="1400" b="1" dirty="0">
+              <a:solidFill>
+                <a:srgbClr val="1E2761"/>
+              </a:solidFill>
+              <a:latin typeface="Calibri"/>
+            </a:endParaRPr>
+          </a:p>
+          <a:p>
+            <a:pPr>
+              <a:lnSpc>
+                <a:spcPts val="1400"/>
+              </a:lnSpc>
+              <a:spcBef>
+                <a:spcPts val="0"/>
+              </a:spcBef>
+            </a:pPr>
+            <a:endParaRPr lang="en-US" sz="1400" dirty="0">
+              <a:solidFill>
+                <a:srgbClr val="1E2761"/>
+              </a:solidFill>
+              <a:latin typeface="Calibri"/>
+            </a:endParaRPr>
+          </a:p>
+          <a:p>
+            <a:pPr>
+              <a:lnSpc>
+                <a:spcPts val="1400"/>
+              </a:lnSpc>
+              <a:spcBef>
+                <a:spcPts val="0"/>
+              </a:spcBef>
+            </a:pPr>
+            <a:endParaRPr lang="en-US" b="1" dirty="0">
+              <a:solidFill>
+                <a:srgbClr val="1E2761"/>
+              </a:solidFill>
+              <a:latin typeface="Calibri"/>
+            </a:endParaRPr>
+          </a:p>
+          <a:p>
+            <a:pPr>
+              <a:lnSpc>
+                <a:spcPts val="1400"/>
+              </a:lnSpc>
+              <a:spcBef>
+                <a:spcPts val="0"/>
+              </a:spcBef>
+            </a:pPr>
+            <a:r>
+              <a:rPr lang="en-US" sz="1800" b="1" dirty="0">
+                <a:solidFill>
+                  <a:srgbClr val="1E2761"/>
+                </a:solidFill>
+                <a:latin typeface="Calibri"/>
+              </a:rPr>
+              <a:t>Seasonal mean imputation</a:t>
+            </a:r>
+          </a:p>
+          <a:p>
+            <a:pPr>
+              <a:lnSpc>
+                <a:spcPts val="1300"/>
+              </a:lnSpc>
+              <a:spcBef>
+                <a:spcPts val="300"/>
+              </a:spcBef>
+            </a:pPr>
+            <a:r>
+              <a:rPr lang="en-US" sz="1400" dirty="0">
+                <a:latin typeface="Calibri"/>
+              </a:rPr>
+              <a:t>Energy demand follows strong daily and weaker weekly cycles. Seasonal (48 slots) mean preserves the daily pattern, avoiding the flat plateau introduced by forward-fill.</a:t>
+            </a:r>
+            <a:br>
+              <a:rPr lang="en-US" sz="1400" dirty="0">
+                <a:latin typeface="Calibri"/>
+              </a:rPr>
+            </a:br>
+            <a:br>
+              <a:rPr lang="en-US" sz="1400" dirty="0">
+                <a:latin typeface="Calibri"/>
+              </a:rPr>
+            </a:br>
+            <a:r>
+              <a:rPr lang="en-US" sz="1400" dirty="0" err="1">
+                <a:latin typeface="Calibri"/>
+              </a:rPr>
+              <a:t>NaN</a:t>
+            </a:r>
+            <a:r>
+              <a:rPr lang="en-US" sz="1400" dirty="0">
+                <a:latin typeface="Calibri"/>
+              </a:rPr>
+              <a:t>-values are filled with mean of </a:t>
+            </a:r>
+            <a:r>
+              <a:rPr lang="en-US" sz="1400" i="1" dirty="0">
+                <a:latin typeface="Calibri"/>
+              </a:rPr>
+              <a:t>all</a:t>
+            </a:r>
+            <a:r>
+              <a:rPr lang="en-US" sz="1400" dirty="0">
+                <a:latin typeface="Calibri"/>
+              </a:rPr>
+              <a:t> previous values at 48-slots intervals. Could be improved with rolling window since the PACF shows drop-off.</a:t>
+            </a:r>
+          </a:p>
+        </p:txBody>
+      </p:sp>
+      <p:pic>
+        <p:nvPicPr>
+          <p:cNvPr id="6" name="Picture 5">
+            <a:extLst>
+              <a:ext uri="{FF2B5EF4-FFF2-40B4-BE49-F238E27FC236}">
+                <a16:creationId xmlns:a16="http://schemas.microsoft.com/office/drawing/2014/main" id="{A808F337-270D-84C4-644A-8B03B2CC5A70}"/>
+              </a:ext>
+            </a:extLst>
+          </p:cNvPr>
+          <p:cNvPicPr>
+            <a:picLocks noChangeAspect="1"/>
+          </p:cNvPicPr>
+          <p:nvPr/>
+        </p:nvPicPr>
+        <p:blipFill>
+          <a:blip r:embed="rId2">
+            <a:extLst>
+              <a:ext uri="{28A0092B-C50C-407E-A947-70E740481C1C}">
+                <a14:useLocalDpi xmlns:a14="http://schemas.microsoft.com/office/drawing/2010/main" val="0"/>
+              </a:ext>
+            </a:extLst>
+          </a:blip>
+          <a:stretch>
+            <a:fillRect/>
+          </a:stretch>
+        </p:blipFill>
+        <p:spPr>
+          <a:xfrm>
+            <a:off x="6772371" y="1059144"/>
+            <a:ext cx="3971829" cy="5727914"/>
+          </a:xfrm>
+          <a:prstGeom prst="rect">
+            <a:avLst/>
+          </a:prstGeom>
+        </p:spPr>
+      </p:pic>
     </p:spTree>
-    <p:extLst>
-      <p:ext uri="{BB962C8B-B14F-4D97-AF65-F5344CB8AC3E}">
-        <p14:creationId xmlns:p14="http://schemas.microsoft.com/office/powerpoint/2010/main" val="839791491"/>
-      </p:ext>
-    </p:extLst>
   </p:cSld>
   <p:clrMapOvr>
     <a:masterClrMapping/>
   </p:clrMapOvr>
-  <p:transition/>
 </p:sld>
 </file>
 
@@ -3530,7 +4228,6 @@
           <a:chExt cx="0" cy="0"/>
         </a:xfrm>
       </p:grpSpPr>
-      <!-- Dark header bar -->
       <p:sp>
         <p:nvSpPr>
           <p:cNvPr id="10" name="HeaderBar"/>
@@ -3562,7 +4259,6 @@
           </a:p>
         </p:txBody>
       </p:sp>
-      <!-- Title in header bar -->
       <p:sp>
         <p:nvSpPr>
           <p:cNvPr id="2" name="Title"/>
@@ -3590,15 +4286,14 @@
                 </a:solidFill>
                 <a:latin typeface="Calibri"/>
               </a:rPr>
-              <a:t>Task 01 – Data Loading &amp; Validation</a:t>
-            </a:r>
-          </a:p>
-        </p:txBody>
-      </p:sp>
-      <!-- LEFT COLUMN: Stats -->
-      <p:sp>
-        <p:nvSpPr>
-          <p:cNvPr id="3" name="LeftContent"/>
+              <a:t>Task 04 – Stationarity &amp; Trend Analysis</a:t>
+            </a:r>
+          </a:p>
+        </p:txBody>
+      </p:sp>
+      <p:sp>
+        <p:nvSpPr>
+          <p:cNvPr id="3" name="ADFColumn"/>
           <p:cNvSpPr>
             <a:spLocks noGrp="1"/>
           </p:cNvSpPr>
@@ -3607,7 +4302,7 @@
         <p:spPr>
           <a:xfrm>
             <a:off x="457200" y="1200000"/>
-            <a:ext cx="5500000" cy="5200000"/>
+            <a:ext cx="5486400" cy="5300000"/>
           </a:xfrm>
           <a:prstGeom prst="rect">
             <a:avLst/>
@@ -3635,7 +4330,29 @@
                 </a:solidFill>
                 <a:latin typeface="Calibri"/>
               </a:rPr>
-              <a:t>Dataset Overview</a:t>
+              <a:t>ADF Stationarity Test (p &lt; 0.05)</a:t>
+            </a:r>
+          </a:p>
+          <a:p>
+            <a:pPr>
+              <a:lnSpc>
+                <a:spcPts val="1300"/>
+              </a:lnSpc>
+              <a:spcBef>
+                <a:spcPts val="300"/>
+              </a:spcBef>
+            </a:pPr>
+            <a:r>
+              <a:rPr lang="en-US" sz="1400" b="1" dirty="0">
+                <a:latin typeface="Calibri"/>
+              </a:rPr>
+              <a:t>All 5 households stationary </a:t>
+            </a:r>
+            <a:r>
+              <a:rPr lang="en-US" sz="1400" dirty="0">
+                <a:latin typeface="Calibri"/>
+              </a:rPr>
+              <a:t>across all regression types (c, ct, ctt)</a:t>
             </a:r>
           </a:p>
           <a:p>
@@ -3651,7 +4368,7 @@
               <a:rPr lang="en-US" sz="1400" dirty="0">
                 <a:latin typeface="Calibri"/>
               </a:rPr>
-              <a:t>Source: UK Power Networks London Smart Meters</a:t>
+              <a:t>MAC000002: ADF = −10.11, p = 0.000 ✓</a:t>
             </a:r>
           </a:p>
           <a:p>
@@ -3664,7 +4381,7 @@
               <a:rPr lang="en-US" sz="1400" dirty="0">
                 <a:latin typeface="Calibri"/>
               </a:rPr>
-              <a:t>Period: 2012-10-12 to 2014-05-23</a:t>
+              <a:t>MAC000003: ADF = −6.63, p = 0.000 ✓</a:t>
             </a:r>
           </a:p>
           <a:p>
@@ -3677,8 +4394,47 @@
               <a:rPr lang="en-US" sz="1400" dirty="0">
                 <a:latin typeface="Calibri"/>
               </a:rPr>
-              <a:t>Total households: 5,566 | Blocks loaded: 3 each</a:t>
-            </a:r>
+              <a:t>MAC000004: ADF = −12.92, p = 0.000 ✓</a:t>
+            </a:r>
+          </a:p>
+          <a:p>
+            <a:pPr>
+              <a:lnSpc>
+                <a:spcPts val="1300"/>
+              </a:lnSpc>
+            </a:pPr>
+            <a:r>
+              <a:rPr lang="en-US" sz="1400" dirty="0">
+                <a:latin typeface="Calibri"/>
+              </a:rPr>
+              <a:t>MAC000005: ADF = −13.36, p = 0.000 ✓</a:t>
+            </a:r>
+          </a:p>
+          <a:p>
+            <a:pPr>
+              <a:lnSpc>
+                <a:spcPts val="1300"/>
+              </a:lnSpc>
+            </a:pPr>
+            <a:r>
+              <a:rPr lang="en-US" sz="1400" dirty="0">
+                <a:latin typeface="Calibri"/>
+              </a:rPr>
+              <a:t>MAC000006: ADF = −9.11, p = 0.000 ✓</a:t>
+            </a:r>
+          </a:p>
+          <a:p>
+            <a:pPr>
+              <a:lnSpc>
+                <a:spcPts val="1300"/>
+              </a:lnSpc>
+            </a:pPr>
+            <a:endParaRPr lang="en-US" sz="1300" i="1" dirty="0">
+              <a:solidFill>
+                <a:srgbClr val="444444"/>
+              </a:solidFill>
+              <a:latin typeface="Calibri"/>
+            </a:endParaRPr>
           </a:p>
           <a:p>
             <a:pPr>
@@ -3686,17 +4442,17 @@
                 <a:spcPts val="1400"/>
               </a:lnSpc>
               <a:spcBef>
-                <a:spcPts val="500"/>
+                <a:spcPts val="0"/>
               </a:spcBef>
             </a:pPr>
             <a:r>
-              <a:rPr lang="en-US" sz="1800" b="1" dirty="0">
+              <a:rPr lang="en-US" sz="1600" b="1" dirty="0">
                 <a:solidFill>
                   <a:srgbClr val="1E2761"/>
                 </a:solidFill>
                 <a:latin typeface="Calibri"/>
               </a:rPr>
-              <a:t>Validation Results</a:t>
+              <a:t>Mann-Kendall Trend Test</a:t>
             </a:r>
           </a:p>
           <a:p>
@@ -3705,59 +4461,155 @@
                 <a:spcPts val="1300"/>
               </a:lnSpc>
               <a:spcBef>
-                <a:spcPts val="200"/>
+                <a:spcPts val="300"/>
               </a:spcBef>
             </a:pPr>
             <a:r>
-              <a:rPr lang="en-US" sz="1400" b="1" dirty="0">
-                <a:latin typeface="Calibri"/>
-              </a:rPr>
-              <a:t xml:space="preserve">Half-hourly: </a:t>
-            </a:r>
-            <a:r>
-              <a:rPr lang="en-US" sz="1400" dirty="0">
-                <a:latin typeface="Calibri"/>
-              </a:rPr>
-              <a:t>4,227,000 rows | 0 duplicates | 0 errors</a:t>
-            </a:r>
-          </a:p>
-          <a:p>
-            <a:pPr>
-              <a:lnSpc>
-                <a:spcPts val="1300"/>
-              </a:lnSpc>
-            </a:pPr>
-            <a:r>
-              <a:rPr lang="en-US" sz="1400" b="1" dirty="0">
-                <a:latin typeface="Calibri"/>
-              </a:rPr>
-              <a:t xml:space="preserve">Daily: </a:t>
-            </a:r>
-            <a:r>
-              <a:rPr lang="en-US" sz="1400" dirty="0">
-                <a:latin typeface="Calibri"/>
-              </a:rPr>
-              <a:t>88,438 rows | 0 duplicates | 0 errors</a:t>
-            </a:r>
-          </a:p>
-          <a:p>
-            <a:pPr>
-              <a:lnSpc>
-                <a:spcPts val="1300"/>
-              </a:lnSpc>
-            </a:pPr>
-            <a:r>
-              <a:rPr lang="en-US" sz="1400" b="1" dirty="0">
-                <a:latin typeface="Calibri"/>
-              </a:rPr>
-              <a:t xml:space="preserve">HHBlock: </a:t>
-            </a:r>
-            <a:r>
-              <a:rPr lang="en-US" sz="1400" dirty="0">
-                <a:latin typeface="Calibri"/>
-              </a:rPr>
-              <a:t>87,300 rows | 0 duplicates | 0 errors</a:t>
-            </a:r>
+              <a:rPr lang="en-US" sz="1200" dirty="0">
+                <a:latin typeface="Calibri"/>
+              </a:rPr>
+              <a:t>MAC000002: </a:t>
+            </a:r>
+            <a:r>
+              <a:rPr lang="en-US" sz="1200" b="1" dirty="0">
+                <a:solidFill>
+                  <a:srgbClr val="C0392B"/>
+                </a:solidFill>
+                <a:latin typeface="Calibri"/>
+              </a:rPr>
+              <a:t>Decreasing trend</a:t>
+            </a:r>
+            <a:r>
+              <a:rPr lang="en-US" sz="1200" dirty="0">
+                <a:latin typeface="Calibri"/>
+              </a:rPr>
+              <a:t> (p=0.000)</a:t>
+            </a:r>
+          </a:p>
+          <a:p>
+            <a:pPr>
+              <a:lnSpc>
+                <a:spcPts val="1300"/>
+              </a:lnSpc>
+            </a:pPr>
+            <a:r>
+              <a:rPr lang="en-US" sz="1200" dirty="0">
+                <a:latin typeface="Calibri"/>
+              </a:rPr>
+              <a:t>MAC000003: </a:t>
+            </a:r>
+            <a:r>
+              <a:rPr lang="en-US" sz="1200" b="1" dirty="0">
+                <a:solidFill>
+                  <a:srgbClr val="C0392B"/>
+                </a:solidFill>
+                <a:latin typeface="Calibri"/>
+              </a:rPr>
+              <a:t>Decreasing trend</a:t>
+            </a:r>
+            <a:r>
+              <a:rPr lang="en-US" sz="1200" dirty="0">
+                <a:latin typeface="Calibri"/>
+              </a:rPr>
+              <a:t> (p=0.000)</a:t>
+            </a:r>
+          </a:p>
+          <a:p>
+            <a:pPr>
+              <a:lnSpc>
+                <a:spcPts val="1300"/>
+              </a:lnSpc>
+            </a:pPr>
+            <a:r>
+              <a:rPr lang="en-US" sz="1200" dirty="0">
+                <a:latin typeface="Calibri"/>
+              </a:rPr>
+              <a:t>MAC000004: </a:t>
+            </a:r>
+            <a:r>
+              <a:rPr lang="en-US" sz="1200" b="1" dirty="0">
+                <a:solidFill>
+                  <a:srgbClr val="27AE60"/>
+                </a:solidFill>
+                <a:latin typeface="Calibri"/>
+              </a:rPr>
+              <a:t>No trend</a:t>
+            </a:r>
+            <a:r>
+              <a:rPr lang="en-US" sz="1200" dirty="0">
+                <a:latin typeface="Calibri"/>
+              </a:rPr>
+              <a:t> (p=0.876)</a:t>
+            </a:r>
+          </a:p>
+          <a:p>
+            <a:pPr>
+              <a:lnSpc>
+                <a:spcPts val="1300"/>
+              </a:lnSpc>
+            </a:pPr>
+            <a:r>
+              <a:rPr lang="en-US" sz="1200" dirty="0">
+                <a:latin typeface="Calibri"/>
+              </a:rPr>
+              <a:t>MAC000005: </a:t>
+            </a:r>
+            <a:r>
+              <a:rPr lang="en-US" sz="1200" b="1" dirty="0">
+                <a:solidFill>
+                  <a:srgbClr val="C0392B"/>
+                </a:solidFill>
+                <a:latin typeface="Calibri"/>
+              </a:rPr>
+              <a:t>Decreasing trend</a:t>
+            </a:r>
+            <a:r>
+              <a:rPr lang="en-US" sz="1200" dirty="0">
+                <a:latin typeface="Calibri"/>
+              </a:rPr>
+              <a:t> (p=0.000)</a:t>
+            </a:r>
+          </a:p>
+          <a:p>
+            <a:pPr>
+              <a:lnSpc>
+                <a:spcPts val="1300"/>
+              </a:lnSpc>
+            </a:pPr>
+            <a:r>
+              <a:rPr lang="en-US" sz="1200" dirty="0">
+                <a:latin typeface="Calibri"/>
+              </a:rPr>
+              <a:t>MAC000006: </a:t>
+            </a:r>
+            <a:r>
+              <a:rPr lang="en-US" sz="1200" b="1" dirty="0">
+                <a:solidFill>
+                  <a:srgbClr val="27AE60"/>
+                </a:solidFill>
+                <a:latin typeface="Calibri"/>
+              </a:rPr>
+              <a:t>No trend</a:t>
+            </a:r>
+            <a:r>
+              <a:rPr lang="en-US" sz="1200" dirty="0">
+                <a:latin typeface="Calibri"/>
+              </a:rPr>
+              <a:t> (p=0.341)</a:t>
+            </a:r>
+          </a:p>
+          <a:p>
+            <a:pPr>
+              <a:lnSpc>
+                <a:spcPts val="1300"/>
+              </a:lnSpc>
+            </a:pPr>
+            <a:endParaRPr lang="en-US" sz="1200" i="1" dirty="0">
+              <a:solidFill>
+                <a:srgbClr val="444444"/>
+              </a:solidFill>
+              <a:latin typeface="Calibri"/>
+            </a:endParaRPr>
           </a:p>
           <a:p>
             <a:pPr>
@@ -3765,17 +4617,17 @@
                 <a:spcPts val="1400"/>
               </a:lnSpc>
               <a:spcBef>
-                <a:spcPts val="500"/>
+                <a:spcPts val="0"/>
               </a:spcBef>
             </a:pPr>
             <a:r>
-              <a:rPr lang="en-US" sz="1800" b="1" dirty="0">
+              <a:rPr lang="en-US" sz="1600" b="1" dirty="0">
                 <a:solidFill>
                   <a:srgbClr val="1E2761"/>
                 </a:solidFill>
                 <a:latin typeface="Calibri"/>
               </a:rPr>
-              <a:t>Key Finding</a:t>
+              <a:t>White Test (Heteroscedasticity)</a:t>
             </a:r>
           </a:p>
           <a:p>
@@ -3784,22 +4636,174 @@
                 <a:spcPts val="1300"/>
               </a:lnSpc>
               <a:spcBef>
-                <a:spcPts val="200"/>
+                <a:spcPts val="300"/>
               </a:spcBef>
             </a:pPr>
             <a:r>
-              <a:rPr lang="en-US" sz="1400" dirty="0">
-                <a:latin typeface="Calibri"/>
-              </a:rPr>
-              <a:t>All three datasets passed validation with zero data quality issues. Dataset is clean and ready for downstream modelling.</a:t>
-            </a:r>
-          </a:p>
-        </p:txBody>
-      </p:sp>
-      <!-- RIGHT: image -->
+              <a:rPr lang="en-US" sz="1200" dirty="0">
+                <a:latin typeface="Calibri"/>
+              </a:rPr>
+              <a:t>MAC000002: LM=20,916, p=0.000 — </a:t>
+            </a:r>
+            <a:r>
+              <a:rPr lang="en-US" sz="1200" b="1" dirty="0">
+                <a:solidFill>
+                  <a:srgbClr val="C0392B"/>
+                </a:solidFill>
+                <a:latin typeface="Calibri"/>
+              </a:rPr>
+              <a:t>Heteroskedastic</a:t>
+            </a:r>
+          </a:p>
+          <a:p>
+            <a:pPr>
+              <a:lnSpc>
+                <a:spcPts val="1300"/>
+              </a:lnSpc>
+            </a:pPr>
+            <a:r>
+              <a:rPr lang="en-US" sz="1200" dirty="0">
+                <a:latin typeface="Calibri"/>
+              </a:rPr>
+              <a:t>MAC000003: LM=32,059, p=0.000 — </a:t>
+            </a:r>
+            <a:r>
+              <a:rPr lang="en-US" sz="1200" b="1" dirty="0">
+                <a:solidFill>
+                  <a:srgbClr val="C0392B"/>
+                </a:solidFill>
+                <a:latin typeface="Calibri"/>
+              </a:rPr>
+              <a:t>Heteroskedastic</a:t>
+            </a:r>
+          </a:p>
+          <a:p>
+            <a:pPr>
+              <a:lnSpc>
+                <a:spcPts val="1300"/>
+              </a:lnSpc>
+            </a:pPr>
+            <a:r>
+              <a:rPr lang="en-US" sz="1200" dirty="0">
+                <a:latin typeface="Calibri"/>
+              </a:rPr>
+              <a:t>MAC000004: LM=28,532, p=0.000 — </a:t>
+            </a:r>
+            <a:r>
+              <a:rPr lang="en-US" sz="1200" b="1" dirty="0">
+                <a:solidFill>
+                  <a:srgbClr val="C0392B"/>
+                </a:solidFill>
+                <a:latin typeface="Calibri"/>
+              </a:rPr>
+              <a:t>Heteroskedastic</a:t>
+            </a:r>
+          </a:p>
+          <a:p>
+            <a:pPr>
+              <a:lnSpc>
+                <a:spcPts val="1300"/>
+              </a:lnSpc>
+            </a:pPr>
+            <a:r>
+              <a:rPr lang="en-US" sz="1200" dirty="0">
+                <a:latin typeface="Calibri"/>
+              </a:rPr>
+              <a:t>MAC000005: LM=27,357, p=0.000 — </a:t>
+            </a:r>
+            <a:r>
+              <a:rPr lang="en-US" sz="1200" b="1" dirty="0">
+                <a:solidFill>
+                  <a:srgbClr val="C0392B"/>
+                </a:solidFill>
+                <a:latin typeface="Calibri"/>
+              </a:rPr>
+              <a:t>Heteroskedastic</a:t>
+            </a:r>
+          </a:p>
+          <a:p>
+            <a:pPr>
+              <a:lnSpc>
+                <a:spcPts val="1300"/>
+              </a:lnSpc>
+            </a:pPr>
+            <a:r>
+              <a:rPr lang="en-US" sz="1200" dirty="0">
+                <a:latin typeface="Calibri"/>
+              </a:rPr>
+              <a:t>MAC000006: LM=33,301, p=0.000 — </a:t>
+            </a:r>
+            <a:r>
+              <a:rPr lang="en-US" sz="1200" b="1" dirty="0">
+                <a:solidFill>
+                  <a:srgbClr val="C0392B"/>
+                </a:solidFill>
+                <a:latin typeface="Calibri"/>
+              </a:rPr>
+              <a:t>Heteroskedastic</a:t>
+            </a:r>
+          </a:p>
+          <a:p>
+            <a:pPr>
+              <a:lnSpc>
+                <a:spcPts val="1300"/>
+              </a:lnSpc>
+              <a:spcBef>
+                <a:spcPts val="400"/>
+              </a:spcBef>
+            </a:pPr>
+            <a:r>
+              <a:rPr lang="en-US" sz="1200" i="1" dirty="0">
+                <a:solidFill>
+                  <a:srgbClr val="444444"/>
+                </a:solidFill>
+                <a:latin typeface="Calibri"/>
+              </a:rPr>
+              <a:t>All households show non-constant variance — log-transform recommended.</a:t>
+            </a:r>
+          </a:p>
+        </p:txBody>
+      </p:sp>
+      <p:sp>
+        <p:nvSpPr>
+          <p:cNvPr id="11" name="Divider"/>
+          <p:cNvSpPr>
+            <a:spLocks noGrp="1"/>
+          </p:cNvSpPr>
+          <p:nvPr/>
+        </p:nvSpPr>
+        <p:spPr>
+          <a:xfrm>
+            <a:off x="6096000" y="1200000"/>
+            <a:ext cx="50000" cy="5300000"/>
+          </a:xfrm>
+          <a:prstGeom prst="rect">
+            <a:avLst/>
+          </a:prstGeom>
+          <a:solidFill>
+            <a:srgbClr val="CADCFC"/>
+          </a:solidFill>
+          <a:ln>
+            <a:noFill/>
+          </a:ln>
+        </p:spPr>
+        <p:txBody>
+          <a:bodyPr/>
+          <a:lstStyle/>
+          <a:p>
+            <a:endParaRPr/>
+          </a:p>
+        </p:txBody>
+      </p:sp>
       <p:pic>
         <p:nvPicPr>
-          <p:cNvPr id="4" name="AvgEnergyImg"/>
+          <p:cNvPr id="13" name="HouseholdSplitsImg">
+            <a:extLst>
+              <a:ext uri="{FF2B5EF4-FFF2-40B4-BE49-F238E27FC236}">
+                <a16:creationId xmlns:a16="http://schemas.microsoft.com/office/drawing/2014/main" id="{48E7F763-C8BC-6196-E80D-EE31BDA0F94B}"/>
+              </a:ext>
+            </a:extLst>
+          </p:cNvPr>
           <p:cNvPicPr>
             <a:picLocks noChangeAspect="1"/>
           </p:cNvPicPr>
@@ -3813,50 +4817,14 @@
         </p:blipFill>
         <p:spPr>
           <a:xfrm>
-            <a:off x="6200000" y="1200000"/>
-            <a:ext cx="5535600" cy="4200000"/>
+            <a:off x="6382295" y="1200000"/>
+            <a:ext cx="5528371" cy="5300000"/>
           </a:xfrm>
           <a:prstGeom prst="rect">
             <a:avLst/>
           </a:prstGeom>
         </p:spPr>
       </p:pic>
-      <!-- Caption -->
-      <p:sp>
-        <p:nvSpPr>
-          <p:cNvPr id="5" name="ImgCaption"/>
-          <p:cNvSpPr>
-            <a:spLocks noGrp="1"/>
-          </p:cNvSpPr>
-          <p:nvPr/>
-        </p:nvSpPr>
-        <p:spPr>
-          <a:xfrm>
-            <a:off x="6200000" y="5450000"/>
-            <a:ext cx="5535600" cy="457200"/>
-          </a:xfrm>
-          <a:prstGeom prst="rect">
-            <a:avLst/>
-          </a:prstGeom>
-          <a:noFill/>
-        </p:spPr>
-        <p:txBody>
-          <a:bodyPr anchor="t"/>
-          <a:lstStyle/>
-          <a:p>
-            <a:pPr algn="ctr"/>
-            <a:r>
-              <a:rPr lang="en-US" sz="1000" i="1" dirty="0">
-                <a:solidFill>
-                  <a:srgbClr val="666666"/>
-                </a:solidFill>
-                <a:latin typeface="Calibri"/>
-              </a:rPr>
-              <a:t>Fig 1: Average energy consumption across training households</a:t>
-            </a:r>
-          </a:p>
-        </p:txBody>
-      </p:sp>
     </p:spTree>
   </p:cSld>
   <p:clrMapOvr>
@@ -3882,7 +4850,6 @@
           <a:chExt cx="0" cy="0"/>
         </a:xfrm>
       </p:grpSpPr>
-      <!-- Dark header bar -->
       <p:sp>
         <p:nvSpPr>
           <p:cNvPr id="10" name="HeaderBar"/>
@@ -3914,7 +4881,6 @@
           </a:p>
         </p:txBody>
       </p:sp>
-      <!-- Title -->
       <p:sp>
         <p:nvSpPr>
           <p:cNvPr id="2" name="Title"/>
@@ -3942,15 +4908,20 @@
                 </a:solidFill>
                 <a:latin typeface="Calibri"/>
               </a:rPr>
-              <a:t>Task 04 – Exploratory Data Analysis</a:t>
-            </a:r>
-          </a:p>
-        </p:txBody>
-      </p:sp>
-      <!-- Subtitle bar -->
-      <p:sp>
-        <p:nvSpPr>
-          <p:cNvPr id="6" name="SubtitleLabel"/>
+              <a:t>Task 04 – Diagnostics &amp;Transforms</a:t>
+            </a:r>
+          </a:p>
+        </p:txBody>
+      </p:sp>
+      <p:sp>
+        <p:nvSpPr>
+          <p:cNvPr id="8" name="RightColumn">
+            <a:extLst>
+              <a:ext uri="{FF2B5EF4-FFF2-40B4-BE49-F238E27FC236}">
+                <a16:creationId xmlns:a16="http://schemas.microsoft.com/office/drawing/2014/main" id="{BA12037A-8CC1-5891-1D38-207F4EE6B735}"/>
+              </a:ext>
+            </a:extLst>
+          </p:cNvPr>
           <p:cNvSpPr>
             <a:spLocks noGrp="1"/>
           </p:cNvSpPr>
@@ -3958,8 +4929,8 @@
         </p:nvSpPr>
         <p:spPr>
           <a:xfrm>
-            <a:off x="457200" y="1100000"/>
-            <a:ext cx="11277600" cy="380000"/>
+            <a:off x="237528" y="1220424"/>
+            <a:ext cx="5600000" cy="5300000"/>
           </a:xfrm>
           <a:prstGeom prst="rect">
             <a:avLst/>
@@ -3967,143 +4938,155 @@
           <a:noFill/>
         </p:spPr>
         <p:txBody>
-          <a:bodyPr anchor="ctr"/>
-          <a:lstStyle/>
-          <a:p>
-            <a:r>
-              <a:rPr lang="en-US" sz="1400" b="1" dirty="0">
+          <a:bodyPr>
+            <a:normAutofit/>
+          </a:bodyPr>
+          <a:lstStyle/>
+          <a:p>
+            <a:pPr>
+              <a:lnSpc>
+                <a:spcPts val="1400"/>
+              </a:lnSpc>
+              <a:spcBef>
+                <a:spcPts val="0"/>
+              </a:spcBef>
+            </a:pPr>
+            <a:r>
+              <a:rPr lang="en-US" sz="1800" b="1" dirty="0">
                 <a:solidFill>
                   <a:srgbClr val="1E2761"/>
                 </a:solidFill>
                 <a:latin typeface="Calibri"/>
               </a:rPr>
-              <a:t>Daily Energy Profiles &amp; Half-Hourly Consumption Patterns</a:t>
-            </a:r>
-          </a:p>
-        </p:txBody>
-      </p:sp>
-      <!-- LEFT image: daily_profile -->
+              <a:t>Diagnostics and transforms</a:t>
+            </a:r>
+          </a:p>
+          <a:p>
+            <a:pPr marL="285750" indent="-285750">
+              <a:lnSpc>
+                <a:spcPts val="1400"/>
+              </a:lnSpc>
+              <a:buFontTx/>
+              <a:buChar char="-"/>
+            </a:pPr>
+            <a:r>
+              <a:rPr lang="en-US" sz="1400" dirty="0">
+                <a:latin typeface="Calibri"/>
+              </a:rPr>
+              <a:t>ADF shows significant periodicity – seasonal transform is fitting</a:t>
+            </a:r>
+          </a:p>
+          <a:p>
+            <a:pPr marL="285750" indent="-285750">
+              <a:lnSpc>
+                <a:spcPts val="1400"/>
+              </a:lnSpc>
+              <a:buFontTx/>
+              <a:buChar char="-"/>
+            </a:pPr>
+            <a:r>
+              <a:rPr lang="en-US" sz="1400" dirty="0">
+                <a:solidFill>
+                  <a:srgbClr val="1E2761"/>
+                </a:solidFill>
+                <a:latin typeface="Calibri"/>
+              </a:rPr>
+              <a:t>White test shows heteroskedasticity and OLS shows left skewed residuals – log-transform is fitting</a:t>
+            </a:r>
+          </a:p>
+          <a:p>
+            <a:pPr marL="285750" indent="-285750">
+              <a:lnSpc>
+                <a:spcPts val="1400"/>
+              </a:lnSpc>
+              <a:buFontTx/>
+              <a:buChar char="-"/>
+            </a:pPr>
+            <a:r>
+              <a:rPr lang="en-US" sz="1400" dirty="0">
+                <a:solidFill>
+                  <a:srgbClr val="1E2761"/>
+                </a:solidFill>
+                <a:latin typeface="Calibri"/>
+              </a:rPr>
+              <a:t>Mann-Kendall trend tests shows significant trends, but they are deemed spurious.</a:t>
+            </a:r>
+          </a:p>
+        </p:txBody>
+      </p:sp>
+      <p:sp>
+        <p:nvSpPr>
+          <p:cNvPr id="9" name="Divider">
+            <a:extLst>
+              <a:ext uri="{FF2B5EF4-FFF2-40B4-BE49-F238E27FC236}">
+                <a16:creationId xmlns:a16="http://schemas.microsoft.com/office/drawing/2014/main" id="{821229E4-CDD7-BB1E-C1B3-BD439F021AC0}"/>
+              </a:ext>
+            </a:extLst>
+          </p:cNvPr>
+          <p:cNvSpPr>
+            <a:spLocks noGrp="1"/>
+          </p:cNvSpPr>
+          <p:nvPr/>
+        </p:nvSpPr>
+        <p:spPr>
+          <a:xfrm>
+            <a:off x="6096000" y="1200000"/>
+            <a:ext cx="50000" cy="5300000"/>
+          </a:xfrm>
+          <a:prstGeom prst="rect">
+            <a:avLst/>
+          </a:prstGeom>
+          <a:solidFill>
+            <a:srgbClr val="CADCFC"/>
+          </a:solidFill>
+          <a:ln>
+            <a:noFill/>
+          </a:ln>
+        </p:spPr>
+        <p:txBody>
+          <a:bodyPr/>
+          <a:lstStyle/>
+          <a:p>
+            <a:endParaRPr/>
+          </a:p>
+        </p:txBody>
+      </p:sp>
       <p:pic>
         <p:nvPicPr>
-          <p:cNvPr id="3" name="DailyProfileImg"/>
+          <p:cNvPr id="12" name="Picture 11">
+            <a:extLst>
+              <a:ext uri="{FF2B5EF4-FFF2-40B4-BE49-F238E27FC236}">
+                <a16:creationId xmlns:a16="http://schemas.microsoft.com/office/drawing/2014/main" id="{E790EC93-4F23-03B0-762D-2EBFD4985345}"/>
+              </a:ext>
+            </a:extLst>
+          </p:cNvPr>
           <p:cNvPicPr>
             <a:picLocks noChangeAspect="1"/>
           </p:cNvPicPr>
           <p:nvPr/>
         </p:nvPicPr>
         <p:blipFill>
-          <a:blip r:embed="rId2"/>
+          <a:blip r:embed="rId2">
+            <a:extLst>
+              <a:ext uri="{28A0092B-C50C-407E-A947-70E740481C1C}">
+                <a14:useLocalDpi xmlns:a14="http://schemas.microsoft.com/office/drawing/2010/main" val="0"/>
+              </a:ext>
+            </a:extLst>
+          </a:blip>
           <a:stretch>
             <a:fillRect/>
           </a:stretch>
         </p:blipFill>
         <p:spPr>
           <a:xfrm>
-            <a:off x="228600" y="1600000"/>
-            <a:ext cx="5700000" cy="4000000"/>
+            <a:off x="6404472" y="1220424"/>
+            <a:ext cx="5477848" cy="5423879"/>
           </a:xfrm>
           <a:prstGeom prst="rect">
             <a:avLst/>
           </a:prstGeom>
         </p:spPr>
       </p:pic>
-      <!-- LEFT caption -->
-      <p:sp>
-        <p:nvSpPr>
-          <p:cNvPr id="4" name="LeftCaption"/>
-          <p:cNvSpPr>
-            <a:spLocks noGrp="1"/>
-          </p:cNvSpPr>
-          <p:nvPr/>
-        </p:nvSpPr>
-        <p:spPr>
-          <a:xfrm>
-            <a:off x="228600" y="5650000"/>
-            <a:ext cx="5700000" cy="457200"/>
-          </a:xfrm>
-          <a:prstGeom prst="rect">
-            <a:avLst/>
-          </a:prstGeom>
-          <a:noFill/>
-        </p:spPr>
-        <p:txBody>
-          <a:bodyPr anchor="t"/>
-          <a:lstStyle/>
-          <a:p>
-            <a:pPr algn="ctr"/>
-            <a:r>
-              <a:rPr lang="en-US" sz="1000" i="1" dirty="0">
-                <a:solidFill>
-                  <a:srgbClr val="666666"/>
-                </a:solidFill>
-                <a:latin typeface="Calibri"/>
-              </a:rPr>
-              <a:t>Fig 2: Average daily energy profile across households</a:t>
-            </a:r>
-          </a:p>
-        </p:txBody>
-      </p:sp>
-      <!-- RIGHT image: halfhourly_zoom -->
-      <p:pic>
-        <p:nvPicPr>
-          <p:cNvPr id="5" name="HalfHourlyImg"/>
-          <p:cNvPicPr>
-            <a:picLocks noChangeAspect="1"/>
-          </p:cNvPicPr>
-          <p:nvPr/>
-        </p:nvPicPr>
-        <p:blipFill>
-          <a:blip r:embed="rId3"/>
-          <a:stretch>
-            <a:fillRect/>
-          </a:stretch>
-        </p:blipFill>
-        <p:spPr>
-          <a:xfrm>
-            <a:off x="6263400" y="1600000"/>
-            <a:ext cx="5700000" cy="4000000"/>
-          </a:xfrm>
-          <a:prstGeom prst="rect">
-            <a:avLst/>
-          </a:prstGeom>
-        </p:spPr>
-      </p:pic>
-      <!-- RIGHT caption -->
-      <p:sp>
-        <p:nvSpPr>
-          <p:cNvPr id="7" name="RightCaption"/>
-          <p:cNvSpPr>
-            <a:spLocks noGrp="1"/>
-          </p:cNvSpPr>
-          <p:nvPr/>
-        </p:nvSpPr>
-        <p:spPr>
-          <a:xfrm>
-            <a:off x="6263400" y="5650000"/>
-            <a:ext cx="5700000" cy="457200"/>
-          </a:xfrm>
-          <a:prstGeom prst="rect">
-            <a:avLst/>
-          </a:prstGeom>
-          <a:noFill/>
-        </p:spPr>
-        <p:txBody>
-          <a:bodyPr anchor="t"/>
-          <a:lstStyle/>
-          <a:p>
-            <a:pPr algn="ctr"/>
-            <a:r>
-              <a:rPr lang="en-US" sz="1000" i="1" dirty="0">
-                <a:solidFill>
-                  <a:srgbClr val="666666"/>
-                </a:solidFill>
-                <a:latin typeface="Calibri"/>
-              </a:rPr>
-              <a:t>Fig 3: Half-hourly consumption zoom (one week sample)</a:t>
-            </a:r>
-          </a:p>
-        </p:txBody>
-      </p:sp>
     </p:spTree>
   </p:cSld>
   <p:clrMapOvr>
@@ -4129,7 +5112,6 @@
           <a:chExt cx="0" cy="0"/>
         </a:xfrm>
       </p:grpSpPr>
-      <!-- Dark header bar -->
       <p:sp>
         <p:nvSpPr>
           <p:cNvPr id="10" name="HeaderBar"/>
@@ -4161,7 +5143,6 @@
           </a:p>
         </p:txBody>
       </p:sp>
-      <!-- Title -->
       <p:sp>
         <p:nvSpPr>
           <p:cNvPr id="2" name="Title"/>
@@ -4189,15 +5170,237 @@
                 </a:solidFill>
                 <a:latin typeface="Calibri"/>
               </a:rPr>
-              <a:t>Task 04 – Autocorrelation Analysis (ACF / PACF)</a:t>
-            </a:r>
-          </a:p>
-        </p:txBody>
-      </p:sp>
-      <!-- Large central ACF/PACF image -->
+              <a:t>Task 06 – Local Model: Single Household</a:t>
+            </a:r>
+          </a:p>
+        </p:txBody>
+      </p:sp>
+      <p:sp>
+        <p:nvSpPr>
+          <p:cNvPr id="3" name="LeftContent"/>
+          <p:cNvSpPr>
+            <a:spLocks noGrp="1"/>
+          </p:cNvSpPr>
+          <p:nvPr/>
+        </p:nvSpPr>
+        <p:spPr>
+          <a:xfrm>
+            <a:off x="457200" y="1200000"/>
+            <a:ext cx="3863340" cy="5200000"/>
+          </a:xfrm>
+          <a:prstGeom prst="rect">
+            <a:avLst/>
+          </a:prstGeom>
+          <a:noFill/>
+        </p:spPr>
+        <p:txBody>
+          <a:bodyPr>
+            <a:normAutofit/>
+          </a:bodyPr>
+          <a:lstStyle/>
+          <a:p>
+            <a:pPr>
+              <a:lnSpc>
+                <a:spcPts val="1400"/>
+              </a:lnSpc>
+              <a:spcBef>
+                <a:spcPts val="0"/>
+              </a:spcBef>
+            </a:pPr>
+            <a:r>
+              <a:rPr lang="en-US" sz="1200" b="1" dirty="0">
+                <a:solidFill>
+                  <a:srgbClr val="1E2761"/>
+                </a:solidFill>
+                <a:latin typeface="Calibri"/>
+              </a:rPr>
+              <a:t>Model Selection</a:t>
+            </a:r>
+          </a:p>
+          <a:p>
+            <a:pPr>
+              <a:lnSpc>
+                <a:spcPts val="1300"/>
+              </a:lnSpc>
+              <a:spcBef>
+                <a:spcPts val="200"/>
+              </a:spcBef>
+            </a:pPr>
+            <a:r>
+              <a:rPr lang="en-US" sz="1050" dirty="0">
+                <a:latin typeface="Calibri"/>
+              </a:rPr>
+              <a:t>Six models compared: </a:t>
+            </a:r>
+            <a:r>
+              <a:rPr lang="en-US" sz="1050" dirty="0" err="1">
+                <a:latin typeface="Calibri"/>
+              </a:rPr>
+              <a:t>LinearRegression</a:t>
+            </a:r>
+            <a:r>
+              <a:rPr lang="en-US" sz="1050" dirty="0">
+                <a:latin typeface="Calibri"/>
+              </a:rPr>
+              <a:t>, Ridge(a=1.0), Lasso(a=0.01), </a:t>
+            </a:r>
+            <a:r>
+              <a:rPr lang="en-US" sz="1050" dirty="0" err="1">
+                <a:latin typeface="Calibri"/>
+              </a:rPr>
+              <a:t>DecisionTree</a:t>
+            </a:r>
+            <a:r>
+              <a:rPr lang="en-US" sz="1050" dirty="0">
+                <a:latin typeface="Calibri"/>
+              </a:rPr>
+              <a:t>(d=8), </a:t>
+            </a:r>
+            <a:r>
+              <a:rPr lang="en-US" sz="1050" dirty="0" err="1">
+                <a:latin typeface="Calibri"/>
+              </a:rPr>
+              <a:t>RandomForest</a:t>
+            </a:r>
+            <a:r>
+              <a:rPr lang="en-US" sz="1050" dirty="0">
+                <a:latin typeface="Calibri"/>
+              </a:rPr>
+              <a:t>, </a:t>
+            </a:r>
+            <a:r>
+              <a:rPr lang="en-US" sz="1050" dirty="0" err="1">
+                <a:latin typeface="Calibri"/>
+              </a:rPr>
+              <a:t>LightGBM</a:t>
+            </a:r>
+            <a:r>
+              <a:rPr lang="en-US" sz="1050" dirty="0">
+                <a:latin typeface="Calibri"/>
+              </a:rPr>
+              <a:t>(l=63)</a:t>
+            </a:r>
+          </a:p>
+          <a:p>
+            <a:pPr>
+              <a:lnSpc>
+                <a:spcPts val="1300"/>
+              </a:lnSpc>
+            </a:pPr>
+            <a:r>
+              <a:rPr lang="en-US" sz="1050" dirty="0">
+                <a:latin typeface="Calibri"/>
+              </a:rPr>
+              <a:t>Transform: Log-</a:t>
+            </a:r>
+            <a:r>
+              <a:rPr lang="en-US" sz="1050" dirty="0" err="1">
+                <a:latin typeface="Calibri"/>
+              </a:rPr>
+              <a:t>deseasonalising</a:t>
+            </a:r>
+            <a:r>
+              <a:rPr lang="en-US" sz="1050" dirty="0">
+                <a:latin typeface="Calibri"/>
+              </a:rPr>
+              <a:t> (period=48), reversible — residuals modelled, inverse-transform applied at inference</a:t>
+            </a:r>
+          </a:p>
+          <a:p>
+            <a:pPr>
+              <a:lnSpc>
+                <a:spcPts val="1300"/>
+              </a:lnSpc>
+            </a:pPr>
+            <a:endParaRPr lang="en-US" sz="1050" dirty="0">
+              <a:latin typeface="Calibri"/>
+            </a:endParaRPr>
+          </a:p>
+          <a:p>
+            <a:pPr>
+              <a:lnSpc>
+                <a:spcPts val="1400"/>
+              </a:lnSpc>
+              <a:spcBef>
+                <a:spcPts val="500"/>
+              </a:spcBef>
+            </a:pPr>
+            <a:r>
+              <a:rPr lang="en-US" sz="1200" b="1" dirty="0">
+                <a:solidFill>
+                  <a:srgbClr val="1E2761"/>
+                </a:solidFill>
+                <a:latin typeface="Calibri"/>
+              </a:rPr>
+              <a:t>Results</a:t>
+            </a:r>
+          </a:p>
+          <a:p>
+            <a:pPr>
+              <a:lnSpc>
+                <a:spcPts val="1300"/>
+              </a:lnSpc>
+              <a:spcBef>
+                <a:spcPts val="200"/>
+              </a:spcBef>
+            </a:pPr>
+            <a:r>
+              <a:rPr lang="en-US" sz="1050" b="1" dirty="0">
+                <a:latin typeface="Calibri"/>
+              </a:rPr>
+              <a:t>Best model: </a:t>
+            </a:r>
+            <a:r>
+              <a:rPr lang="en-US" sz="1050" dirty="0">
+                <a:latin typeface="Calibri"/>
+              </a:rPr>
+              <a:t>LightGBM(l=63)</a:t>
+            </a:r>
+          </a:p>
+          <a:p>
+            <a:pPr>
+              <a:lnSpc>
+                <a:spcPts val="1300"/>
+              </a:lnSpc>
+            </a:pPr>
+            <a:r>
+              <a:rPr lang="en-US" sz="1050" dirty="0">
+                <a:latin typeface="Calibri"/>
+              </a:rPr>
+              <a:t>Val MASE: 0.550 | Test MASE: 0.568</a:t>
+            </a:r>
+          </a:p>
+          <a:p>
+            <a:pPr>
+              <a:lnSpc>
+                <a:spcPts val="1300"/>
+              </a:lnSpc>
+            </a:pPr>
+            <a:r>
+              <a:rPr lang="en-US" sz="1050" dirty="0">
+                <a:latin typeface="Calibri"/>
+              </a:rPr>
+              <a:t>Val MAE: 0.085 | Test MAE: 0.088</a:t>
+            </a:r>
+          </a:p>
+          <a:p>
+            <a:pPr>
+              <a:lnSpc>
+                <a:spcPts val="1300"/>
+              </a:lnSpc>
+            </a:pPr>
+            <a:r>
+              <a:rPr lang="en-US" sz="1050" dirty="0">
+                <a:latin typeface="Calibri"/>
+              </a:rPr>
+              <a:t>ACF lag-1: -0.126 (significant)</a:t>
+            </a:r>
+          </a:p>
+        </p:txBody>
+      </p:sp>
       <p:pic>
         <p:nvPicPr>
-          <p:cNvPr id="3" name="ACFPACFImg"/>
+          <p:cNvPr id="4" name="ResidualAnalysisImg"/>
           <p:cNvPicPr>
             <a:picLocks noChangeAspect="1"/>
           </p:cNvPicPr>
@@ -4211,18 +5414,17 @@
         </p:blipFill>
         <p:spPr>
           <a:xfrm>
-            <a:off x="457200" y="1150000"/>
-            <a:ext cx="8500000" cy="5300000"/>
+            <a:off x="4320540" y="1200000"/>
+            <a:ext cx="7415060" cy="4200000"/>
           </a:xfrm>
           <a:prstGeom prst="rect">
             <a:avLst/>
           </a:prstGeom>
         </p:spPr>
       </p:pic>
-      <!-- RIGHT: interpretation text -->
-      <p:sp>
-        <p:nvSpPr>
-          <p:cNvPr id="4" name="Interpretation"/>
+      <p:sp>
+        <p:nvSpPr>
+          <p:cNvPr id="5" name="ImgCaption"/>
           <p:cNvSpPr>
             <a:spLocks noGrp="1"/>
           </p:cNvSpPr>
@@ -4230,8 +5432,8 @@
         </p:nvSpPr>
         <p:spPr>
           <a:xfrm>
-            <a:off x="9200000" y="1150000"/>
-            <a:ext cx="2764800" cy="5300000"/>
+            <a:off x="6200000" y="5450000"/>
+            <a:ext cx="5535600" cy="457200"/>
           </a:xfrm>
           <a:prstGeom prst="rect">
             <a:avLst/>
@@ -4239,133 +5441,6 @@
           <a:noFill/>
         </p:spPr>
         <p:txBody>
-          <a:bodyPr>
-            <a:normAutofit/>
-          </a:bodyPr>
-          <a:lstStyle/>
-          <a:p>
-            <a:pPr>
-              <a:lnSpc>
-                <a:spcPts val="1400"/>
-              </a:lnSpc>
-              <a:spcBef>
-                <a:spcPts val="0"/>
-              </a:spcBef>
-            </a:pPr>
-            <a:r>
-              <a:rPr lang="en-US" sz="1600" b="1" dirty="0">
-                <a:solidFill>
-                  <a:srgbClr val="1E2761"/>
-                </a:solidFill>
-                <a:latin typeface="Calibri"/>
-              </a:rPr>
-              <a:t>Key Observations</a:t>
-            </a:r>
-          </a:p>
-          <a:p>
-            <a:pPr>
-              <a:lnSpc>
-                <a:spcPts val="1300"/>
-              </a:lnSpc>
-              <a:spcBef>
-                <a:spcPts val="300"/>
-              </a:spcBef>
-            </a:pPr>
-            <a:r>
-              <a:rPr lang="en-US" sz="1300" b="1" dirty="0">
-                <a:latin typeface="Calibri"/>
-              </a:rPr>
-              <a:t xml:space="preserve">ACF lag-48: </a:t>
-            </a:r>
-            <a:r>
-              <a:rPr lang="en-US" sz="1300" dirty="0">
-                <a:latin typeface="Calibri"/>
-              </a:rPr>
-              <a:t>0.39–0.87 (strong daily seasonality)</a:t>
-            </a:r>
-          </a:p>
-          <a:p>
-            <a:pPr>
-              <a:lnSpc>
-                <a:spcPts val="1300"/>
-              </a:lnSpc>
-              <a:spcBef>
-                <a:spcPts val="300"/>
-              </a:spcBef>
-            </a:pPr>
-            <a:r>
-              <a:rPr lang="en-US" sz="1300" b="1" dirty="0">
-                <a:latin typeface="Calibri"/>
-              </a:rPr>
-              <a:t xml:space="preserve">ACF lag-336: </a:t>
-            </a:r>
-            <a:r>
-              <a:rPr lang="en-US" sz="1300" dirty="0">
-                <a:latin typeface="Calibri"/>
-              </a:rPr>
-              <a:t>−0.005–0.74 (weekly pattern in most households)</a:t>
-            </a:r>
-          </a:p>
-          <a:p>
-            <a:pPr>
-              <a:lnSpc>
-                <a:spcPts val="1300"/>
-              </a:lnSpc>
-              <a:spcBef>
-                <a:spcPts val="300"/>
-              </a:spcBef>
-            </a:pPr>
-            <a:r>
-              <a:rPr lang="en-US" sz="1300" b="1" dirty="0">
-                <a:latin typeface="Calibri"/>
-              </a:rPr>
-              <a:t xml:space="preserve">PACF: </a:t>
-            </a:r>
-            <a:r>
-              <a:rPr lang="en-US" sz="1300" dirty="0">
-                <a:latin typeface="Calibri"/>
-              </a:rPr>
-              <a:t>Sharp cut-off after lag 1–2 suggests AR(1/2) structure</a:t>
-            </a:r>
-          </a:p>
-          <a:p>
-            <a:pPr>
-              <a:lnSpc>
-                <a:spcPts val="1300"/>
-              </a:lnSpc>
-              <a:spcBef>
-                <a:spcPts val="300"/>
-              </a:spcBef>
-            </a:pPr>
-            <a:r>
-              <a:rPr lang="en-US" sz="1300" dirty="0">
-                <a:latin typeface="Calibri"/>
-              </a:rPr>
-              <a:t>Periodic spikes confirm seasonal model components are needed.</a:t>
-            </a:r>
-          </a:p>
-        </p:txBody>
-      </p:sp>
-      <!-- Caption -->
-      <p:sp>
-        <p:nvSpPr>
-          <p:cNvPr id="5" name="Caption"/>
-          <p:cNvSpPr>
-            <a:spLocks noGrp="1"/>
-          </p:cNvSpPr>
-          <p:nvPr/>
-        </p:nvSpPr>
-        <p:spPr>
-          <a:xfrm>
-            <a:off x="457200" y="6500000"/>
-            <a:ext cx="8500000" cy="300000"/>
-          </a:xfrm>
-          <a:prstGeom prst="rect">
-            <a:avLst/>
-          </a:prstGeom>
-          <a:noFill/>
-        </p:spPr>
-        <p:txBody>
           <a:bodyPr anchor="t"/>
           <a:lstStyle/>
           <a:p>
@@ -4377,7 +5452,7 @@
                 </a:solidFill>
                 <a:latin typeface="Calibri"/>
               </a:rPr>
-              <a:t>Fig 4: ACF and PACF plots for 5 sample households (half-hourly data)</a:t>
+              <a:t>Fig 6: Residual analysis — LightGBM on household MAC000002 after log-deseasonalising</a:t>
             </a:r>
           </a:p>
         </p:txBody>
@@ -4407,7 +5482,6 @@
           <a:chExt cx="0" cy="0"/>
         </a:xfrm>
       </p:grpSpPr>
-      <!-- Dark header bar -->
       <p:sp>
         <p:nvSpPr>
           <p:cNvPr id="10" name="HeaderBar"/>
@@ -4439,7 +5513,6 @@
           </a:p>
         </p:txBody>
       </p:sp>
-      <!-- Title -->
       <p:sp>
         <p:nvSpPr>
           <p:cNvPr id="2" name="Title"/>
@@ -4467,15 +5540,235 @@
                 </a:solidFill>
                 <a:latin typeface="Calibri"/>
               </a:rPr>
-              <a:t>Task 04 – Household Data Quality &amp; Train/Test Splits</a:t>
-            </a:r>
-          </a:p>
-        </p:txBody>
-      </p:sp>
-      <!-- Large image -->
+              <a:t>Task 07 – Local Cohort Analysis</a:t>
+            </a:r>
+          </a:p>
+        </p:txBody>
+      </p:sp>
+      <p:sp>
+        <p:nvSpPr>
+          <p:cNvPr id="3" name="LeftContent"/>
+          <p:cNvSpPr>
+            <a:spLocks noGrp="1"/>
+          </p:cNvSpPr>
+          <p:nvPr/>
+        </p:nvSpPr>
+        <p:spPr>
+          <a:xfrm>
+            <a:off x="457200" y="1200000"/>
+            <a:ext cx="6256020" cy="5200000"/>
+          </a:xfrm>
+          <a:prstGeom prst="rect">
+            <a:avLst/>
+          </a:prstGeom>
+          <a:noFill/>
+        </p:spPr>
+        <p:txBody>
+          <a:bodyPr>
+            <a:normAutofit/>
+          </a:bodyPr>
+          <a:lstStyle/>
+          <a:p>
+            <a:pPr>
+              <a:lnSpc>
+                <a:spcPts val="1400"/>
+              </a:lnSpc>
+              <a:spcBef>
+                <a:spcPts val="0"/>
+              </a:spcBef>
+            </a:pPr>
+            <a:r>
+              <a:rPr lang="en-US" sz="1400" b="1" dirty="0">
+                <a:solidFill>
+                  <a:srgbClr val="1E2761"/>
+                </a:solidFill>
+                <a:latin typeface="Calibri"/>
+              </a:rPr>
+              <a:t>Cohort-Level Results</a:t>
+            </a:r>
+          </a:p>
+          <a:p>
+            <a:pPr>
+              <a:lnSpc>
+                <a:spcPts val="1300"/>
+              </a:lnSpc>
+              <a:spcBef>
+                <a:spcPts val="200"/>
+              </a:spcBef>
+            </a:pPr>
+            <a:r>
+              <a:rPr lang="en-US" sz="1100" dirty="0">
+                <a:latin typeface="Calibri"/>
+              </a:rPr>
+              <a:t>Same LightGBM + log-deseasonalising pipeline applied to the full cohort (50 households)</a:t>
+            </a:r>
+          </a:p>
+          <a:p>
+            <a:pPr>
+              <a:lnSpc>
+                <a:spcPts val="1300"/>
+              </a:lnSpc>
+            </a:pPr>
+            <a:r>
+              <a:rPr lang="en-US" sz="1100" dirty="0">
+                <a:latin typeface="Calibri"/>
+              </a:rPr>
+              <a:t>Cohort mean test MASE: 0.711 | std: 0.187</a:t>
+            </a:r>
+          </a:p>
+          <a:p>
+            <a:pPr>
+              <a:lnSpc>
+                <a:spcPts val="1300"/>
+              </a:lnSpc>
+            </a:pPr>
+            <a:endParaRPr lang="en-US" sz="1100" dirty="0">
+              <a:latin typeface="Calibri"/>
+            </a:endParaRPr>
+          </a:p>
+          <a:p>
+            <a:pPr>
+              <a:lnSpc>
+                <a:spcPts val="1400"/>
+              </a:lnSpc>
+              <a:spcBef>
+                <a:spcPts val="500"/>
+              </a:spcBef>
+            </a:pPr>
+            <a:r>
+              <a:rPr lang="en-US" sz="1400" b="1" dirty="0">
+                <a:solidFill>
+                  <a:srgbClr val="1E2761"/>
+                </a:solidFill>
+                <a:latin typeface="Calibri"/>
+              </a:rPr>
+              <a:t>ACORN Subgroup Analysis</a:t>
+            </a:r>
+          </a:p>
+          <a:p>
+            <a:pPr>
+              <a:lnSpc>
+                <a:spcPts val="1300"/>
+              </a:lnSpc>
+              <a:spcBef>
+                <a:spcPts val="200"/>
+              </a:spcBef>
+            </a:pPr>
+            <a:r>
+              <a:rPr lang="en-US" sz="1100" dirty="0">
+                <a:latin typeface="Calibri"/>
+              </a:rPr>
+              <a:t>Households split by ACORN classification (Affluent, Comfortable, Adversity)</a:t>
+            </a:r>
+          </a:p>
+          <a:p>
+            <a:pPr>
+              <a:lnSpc>
+                <a:spcPts val="1300"/>
+              </a:lnSpc>
+            </a:pPr>
+            <a:r>
+              <a:rPr lang="en-US" sz="1100" dirty="0">
+                <a:latin typeface="Calibri"/>
+              </a:rPr>
+              <a:t>No strong subgroup effect observed — individual household variance dominates</a:t>
+            </a:r>
+          </a:p>
+          <a:p>
+            <a:pPr>
+              <a:lnSpc>
+                <a:spcPts val="1300"/>
+              </a:lnSpc>
+            </a:pPr>
+            <a:r>
+              <a:rPr lang="en-US" sz="1100" dirty="0">
+                <a:latin typeface="Calibri"/>
+              </a:rPr>
+              <a:t>Easy households (low consumption variance): mean MASE: 0.44</a:t>
+            </a:r>
+          </a:p>
+          <a:p>
+            <a:pPr>
+              <a:lnSpc>
+                <a:spcPts val="1300"/>
+              </a:lnSpc>
+            </a:pPr>
+            <a:r>
+              <a:rPr lang="en-US" sz="1100" dirty="0">
+                <a:latin typeface="Calibri"/>
+              </a:rPr>
+              <a:t>Hard households (erratic patterns): mean MASE: 1.11</a:t>
+            </a:r>
+          </a:p>
+          <a:p>
+            <a:pPr>
+              <a:lnSpc>
+                <a:spcPts val="1300"/>
+              </a:lnSpc>
+            </a:pPr>
+            <a:endParaRPr lang="en-US" sz="1100" dirty="0">
+              <a:latin typeface="Calibri"/>
+            </a:endParaRPr>
+          </a:p>
+          <a:p>
+            <a:pPr>
+              <a:lnSpc>
+                <a:spcPts val="1400"/>
+              </a:lnSpc>
+              <a:spcBef>
+                <a:spcPts val="500"/>
+              </a:spcBef>
+            </a:pPr>
+            <a:r>
+              <a:rPr lang="en-US" sz="1400" b="1" dirty="0">
+                <a:solidFill>
+                  <a:srgbClr val="1E2761"/>
+                </a:solidFill>
+                <a:latin typeface="Calibri"/>
+              </a:rPr>
+              <a:t>Key Finding</a:t>
+            </a:r>
+          </a:p>
+          <a:p>
+            <a:pPr>
+              <a:lnSpc>
+                <a:spcPts val="1300"/>
+              </a:lnSpc>
+              <a:spcBef>
+                <a:spcPts val="200"/>
+              </a:spcBef>
+            </a:pPr>
+            <a:r>
+              <a:rPr lang="en-US" sz="1100" dirty="0">
+                <a:latin typeface="Calibri"/>
+              </a:rPr>
+              <a:t>Forecasting difficulty is driven more by household behavioural variance than by demographic group</a:t>
+            </a:r>
+          </a:p>
+          <a:p>
+            <a:pPr>
+              <a:lnSpc>
+                <a:spcPts val="1300"/>
+              </a:lnSpc>
+            </a:pPr>
+            <a:r>
+              <a:rPr lang="en-US" sz="1100" dirty="0">
+                <a:latin typeface="Calibri"/>
+              </a:rPr>
+              <a:t>Local per-household models are necessary: pooling would sacrifice accuracy on stable households</a:t>
+            </a:r>
+          </a:p>
+        </p:txBody>
+      </p:sp>
       <p:pic>
         <p:nvPicPr>
-          <p:cNvPr id="3" name="HouseholdSplitsImg"/>
+          <p:cNvPr id="7" name="Picture 6">
+            <a:extLst>
+              <a:ext uri="{FF2B5EF4-FFF2-40B4-BE49-F238E27FC236}">
+                <a16:creationId xmlns:a16="http://schemas.microsoft.com/office/drawing/2014/main" id="{71C2246F-8710-D38A-2742-014C00D6E68C}"/>
+              </a:ext>
+            </a:extLst>
+          </p:cNvPr>
           <p:cNvPicPr>
             <a:picLocks noChangeAspect="1"/>
           </p:cNvPicPr>
@@ -4489,181 +5782,50 @@
         </p:blipFill>
         <p:spPr>
           <a:xfrm>
-            <a:off x="228600" y="1150000"/>
-            <a:ext cx="8800000" cy="5300000"/>
+            <a:off x="457200" y="3708179"/>
+            <a:ext cx="3802380" cy="2691821"/>
           </a:xfrm>
           <a:prstGeom prst="rect">
             <a:avLst/>
           </a:prstGeom>
         </p:spPr>
       </p:pic>
-      <!-- RIGHT: text summary -->
-      <p:sp>
-        <p:nvSpPr>
-          <p:cNvPr id="4" name="SummaryText"/>
-          <p:cNvSpPr>
-            <a:spLocks noGrp="1"/>
-          </p:cNvSpPr>
+      <p:pic>
+        <p:nvPicPr>
+          <p:cNvPr id="9" name="Picture 8">
+            <a:extLst>
+              <a:ext uri="{FF2B5EF4-FFF2-40B4-BE49-F238E27FC236}">
+                <a16:creationId xmlns:a16="http://schemas.microsoft.com/office/drawing/2014/main" id="{9B6E17FF-3BEA-71D8-10DF-FA260822E0CA}"/>
+              </a:ext>
+            </a:extLst>
+          </p:cNvPr>
+          <p:cNvPicPr>
+            <a:picLocks noChangeAspect="1"/>
+          </p:cNvPicPr>
           <p:nvPr/>
-        </p:nvSpPr>
+        </p:nvPicPr>
+        <p:blipFill>
+          <a:blip r:embed="rId3">
+            <a:extLst>
+              <a:ext uri="{28A0092B-C50C-407E-A947-70E740481C1C}">
+                <a14:useLocalDpi xmlns:a14="http://schemas.microsoft.com/office/drawing/2010/main" val="0"/>
+              </a:ext>
+            </a:extLst>
+          </a:blip>
+          <a:stretch>
+            <a:fillRect/>
+          </a:stretch>
+        </p:blipFill>
         <p:spPr>
           <a:xfrm>
-            <a:off x="9300000" y="1150000"/>
-            <a:ext cx="2664600" cy="5300000"/>
+            <a:off x="6713220" y="1172986"/>
+            <a:ext cx="5280660" cy="4485014"/>
           </a:xfrm>
           <a:prstGeom prst="rect">
             <a:avLst/>
           </a:prstGeom>
-          <a:noFill/>
         </p:spPr>
-        <p:txBody>
-          <a:bodyPr>
-            <a:normAutofit/>
-          </a:bodyPr>
-          <a:lstStyle/>
-          <a:p>
-            <a:pPr>
-              <a:lnSpc>
-                <a:spcPts val="1400"/>
-              </a:lnSpc>
-              <a:spcBef>
-                <a:spcPts val="0"/>
-              </a:spcBef>
-            </a:pPr>
-            <a:r>
-              <a:rPr lang="en-US" sz="1600" b="1" dirty="0">
-                <a:solidFill>
-                  <a:srgbClr val="1E2761"/>
-                </a:solidFill>
-                <a:latin typeface="Calibri"/>
-              </a:rPr>
-              <a:t>Quality Criteria</a:t>
-            </a:r>
-          </a:p>
-          <a:p>
-            <a:pPr>
-              <a:lnSpc>
-                <a:spcPts val="1300"/>
-              </a:lnSpc>
-              <a:spcBef>
-                <a:spcPts val="300"/>
-              </a:spcBef>
-            </a:pPr>
-            <a:r>
-              <a:rPr lang="en-US" sz="1300" dirty="0">
-                <a:latin typeface="Calibri"/>
-              </a:rPr>
-              <a:t>Households filtered for sufficient data coverage across both train and test periods.</a:t>
-            </a:r>
-          </a:p>
-          <a:p>
-            <a:pPr>
-              <a:lnSpc>
-                <a:spcPts val="1400"/>
-              </a:lnSpc>
-              <a:spcBef>
-                <a:spcPts val="500"/>
-              </a:spcBef>
-            </a:pPr>
-            <a:r>
-              <a:rPr lang="en-US" sz="1600" b="1" dirty="0">
-                <a:solidFill>
-                  <a:srgbClr val="1E2761"/>
-                </a:solidFill>
-                <a:latin typeface="Calibri"/>
-              </a:rPr>
-              <a:t>Split Strategy</a:t>
-            </a:r>
-          </a:p>
-          <a:p>
-            <a:pPr>
-              <a:lnSpc>
-                <a:spcPts val="1300"/>
-              </a:lnSpc>
-              <a:spcBef>
-                <a:spcPts val="300"/>
-              </a:spcBef>
-            </a:pPr>
-            <a:r>
-              <a:rPr lang="en-US" sz="1300" dirty="0">
-                <a:latin typeface="Calibri"/>
-              </a:rPr>
-              <a:t>Chronological train/test split preserving temporal order to avoid data leakage.</a:t>
-            </a:r>
-          </a:p>
-          <a:p>
-            <a:pPr>
-              <a:lnSpc>
-                <a:spcPts val="1400"/>
-              </a:lnSpc>
-              <a:spcBef>
-                <a:spcPts val="500"/>
-              </a:spcBef>
-            </a:pPr>
-            <a:r>
-              <a:rPr lang="en-US" sz="1600" b="1" dirty="0">
-                <a:solidFill>
-                  <a:srgbClr val="1E2761"/>
-                </a:solidFill>
-                <a:latin typeface="Calibri"/>
-              </a:rPr>
-              <a:t>Result</a:t>
-            </a:r>
-          </a:p>
-          <a:p>
-            <a:pPr>
-              <a:lnSpc>
-                <a:spcPts val="1300"/>
-              </a:lnSpc>
-              <a:spcBef>
-                <a:spcPts val="300"/>
-              </a:spcBef>
-            </a:pPr>
-            <a:r>
-              <a:rPr lang="en-US" sz="1300" dirty="0">
-                <a:latin typeface="Calibri"/>
-              </a:rPr>
-              <a:t>5 high-quality households selected for detailed analysis.</a:t>
-            </a:r>
-          </a:p>
-        </p:txBody>
-      </p:sp>
-      <!-- Caption -->
-      <p:sp>
-        <p:nvSpPr>
-          <p:cNvPr id="5" name="Caption"/>
-          <p:cNvSpPr>
-            <a:spLocks noGrp="1"/>
-          </p:cNvSpPr>
-          <p:nvPr/>
-        </p:nvSpPr>
-        <p:spPr>
-          <a:xfrm>
-            <a:off x="228600" y="6500000"/>
-            <a:ext cx="8800000" cy="300000"/>
-          </a:xfrm>
-          <a:prstGeom prst="rect">
-            <a:avLst/>
-          </a:prstGeom>
-          <a:noFill/>
-        </p:spPr>
-        <p:txBody>
-          <a:bodyPr anchor="t"/>
-          <a:lstStyle/>
-          <a:p>
-            <a:pPr algn="ctr"/>
-            <a:r>
-              <a:rPr lang="en-US" sz="1000" i="1" dirty="0">
-                <a:solidFill>
-                  <a:srgbClr val="666666"/>
-                </a:solidFill>
-                <a:latin typeface="Calibri"/>
-              </a:rPr>
-              <a:t>Fig 5: Household time series with train/test split boundaries</a:t>
-            </a:r>
-          </a:p>
-        </p:txBody>
-      </p:sp>
+      </p:pic>
     </p:spTree>
   </p:cSld>
   <p:clrMapOvr>
@@ -4689,7 +5851,6 @@
           <a:chExt cx="0" cy="0"/>
         </a:xfrm>
       </p:grpSpPr>
-      <!-- Dark header bar -->
       <p:sp>
         <p:nvSpPr>
           <p:cNvPr id="10" name="HeaderBar"/>
@@ -4721,7 +5882,6 @@
           </a:p>
         </p:txBody>
       </p:sp>
-      <!-- Title -->
       <p:sp>
         <p:nvSpPr>
           <p:cNvPr id="2" name="Title"/>
@@ -4749,15 +5909,14 @@
                 </a:solidFill>
                 <a:latin typeface="Calibri"/>
               </a:rPr>
-              <a:t>Task 04 – Stationarity &amp; Trend Analysis</a:t>
-            </a:r>
-          </a:p>
-        </p:txBody>
-      </p:sp>
-      <!-- LEFT COLUMN: ADF Stationarity -->
-      <p:sp>
-        <p:nvSpPr>
-          <p:cNvPr id="3" name="ADFColumn"/>
+              <a:t>Task 08 – Global vs Local Models</a:t>
+            </a:r>
+          </a:p>
+        </p:txBody>
+      </p:sp>
+      <p:sp>
+        <p:nvSpPr>
+          <p:cNvPr id="3" name="LeftContent"/>
           <p:cNvSpPr>
             <a:spLocks noGrp="1"/>
           </p:cNvSpPr>
@@ -4766,7 +5925,7 @@
         <p:spPr>
           <a:xfrm>
             <a:off x="457200" y="1200000"/>
-            <a:ext cx="5486400" cy="5300000"/>
+            <a:ext cx="5500000" cy="5200000"/>
           </a:xfrm>
           <a:prstGeom prst="rect">
             <a:avLst/>
@@ -4794,29 +5953,7 @@
                 </a:solidFill>
                 <a:latin typeface="Calibri"/>
               </a:rPr>
-              <a:t>ADF Stationarity Test (p &lt; 0.05)</a:t>
-            </a:r>
-          </a:p>
-          <a:p>
-            <a:pPr>
-              <a:lnSpc>
-                <a:spcPts val="1300"/>
-              </a:lnSpc>
-              <a:spcBef>
-                <a:spcPts val="300"/>
-              </a:spcBef>
-            </a:pPr>
-            <a:r>
-              <a:rPr lang="en-US" sz="1400" b="1" dirty="0">
-                <a:latin typeface="Calibri"/>
-              </a:rPr>
-              <a:t xml:space="preserve">All 5 households stationary </a:t>
-            </a:r>
-            <a:r>
-              <a:rPr lang="en-US" sz="1400" dirty="0">
-                <a:latin typeface="Calibri"/>
-              </a:rPr>
-              <a:t>across all regression types (c, ct, ctt)</a:t>
+              <a:t>Global Forecasting Model (GFM)</a:t>
             </a:r>
           </a:p>
           <a:p>
@@ -4832,7 +5969,7 @@
               <a:rPr lang="en-US" sz="1400" dirty="0">
                 <a:latin typeface="Calibri"/>
               </a:rPr>
-              <a:t>MAC000002: ADF = −10.11, p = 0.000 ✓</a:t>
+              <a:t>One LightGBM trained on ALL households simultaneously (pooled data)</a:t>
             </a:r>
           </a:p>
           <a:p>
@@ -4845,33 +5982,97 @@
               <a:rPr lang="en-US" sz="1400" dirty="0">
                 <a:latin typeface="Calibri"/>
               </a:rPr>
-              <a:t>MAC000003: ADF = −6.63, p = 0.000 ✓</a:t>
-            </a:r>
-          </a:p>
-          <a:p>
-            <a:pPr>
-              <a:lnSpc>
-                <a:spcPts val="1300"/>
-              </a:lnSpc>
+              <a:t>Learns shared patterns across the population</a:t>
+            </a:r>
+          </a:p>
+          <a:p>
+            <a:pPr>
+              <a:lnSpc>
+                <a:spcPts val="1300"/>
+              </a:lnSpc>
+            </a:pPr>
+            <a:endParaRPr lang="en-US" sz="1400" dirty="0">
+              <a:latin typeface="Calibri"/>
+            </a:endParaRPr>
+          </a:p>
+          <a:p>
+            <a:pPr>
+              <a:lnSpc>
+                <a:spcPts val="1400"/>
+              </a:lnSpc>
+              <a:spcBef>
+                <a:spcPts val="500"/>
+              </a:spcBef>
+            </a:pPr>
+            <a:r>
+              <a:rPr lang="en-US" sz="1800" b="1" dirty="0">
+                <a:solidFill>
+                  <a:srgbClr val="1E2761"/>
+                </a:solidFill>
+                <a:latin typeface="Calibri"/>
+              </a:rPr>
+              <a:t>Head-to-Head Comparison</a:t>
+            </a:r>
+          </a:p>
+          <a:p>
+            <a:pPr>
+              <a:lnSpc>
+                <a:spcPts val="1300"/>
+              </a:lnSpc>
+              <a:spcBef>
+                <a:spcPts val="200"/>
+              </a:spcBef>
+            </a:pPr>
+            <a:r>
+              <a:rPr lang="en-US" sz="1400" b="1" dirty="0">
+                <a:latin typeface="Calibri"/>
+              </a:rPr>
+              <a:t>Local models (Task 7)</a:t>
+            </a:r>
+          </a:p>
+          <a:p>
+            <a:pPr>
+              <a:lnSpc>
+                <a:spcPts val="1300"/>
+              </a:lnSpc>
+              <a:spcBef>
+                <a:spcPts val="200"/>
+              </a:spcBef>
             </a:pPr>
             <a:r>
               <a:rPr lang="en-US" sz="1400" dirty="0">
                 <a:latin typeface="Calibri"/>
               </a:rPr>
-              <a:t>MAC000004: ADF = −12.92, p = 0.000 ✓</a:t>
-            </a:r>
-          </a:p>
-          <a:p>
-            <a:pPr>
-              <a:lnSpc>
-                <a:spcPts val="1300"/>
-              </a:lnSpc>
+              <a:t>Val MASE 0.726 | Test MASE 0.711</a:t>
+            </a:r>
+          </a:p>
+          <a:p>
+            <a:pPr>
+              <a:lnSpc>
+                <a:spcPts val="1300"/>
+              </a:lnSpc>
+              <a:spcBef>
+                <a:spcPts val="200"/>
+              </a:spcBef>
             </a:pPr>
             <a:r>
               <a:rPr lang="en-US" sz="1400" dirty="0">
                 <a:latin typeface="Calibri"/>
               </a:rPr>
-              <a:t>MAC000005: ADF = −13.36, p = 0.000 ✓</a:t>
+              <a:t>Val RMSE 0.223 | Test RMSE 0.219</a:t>
+            </a:r>
+          </a:p>
+          <a:p>
+            <a:pPr>
+              <a:lnSpc>
+                <a:spcPts val="1300"/>
+              </a:lnSpc>
+            </a:pPr>
+            <a:r>
+              <a:rPr lang="en-US" sz="1400" b="1" dirty="0">
+                <a:latin typeface="Calibri"/>
+              </a:rPr>
+              <a:t>Global model (Task 8)</a:t>
             </a:r>
           </a:p>
           <a:p>
@@ -4884,269 +6085,108 @@
               <a:rPr lang="en-US" sz="1400" dirty="0">
                 <a:latin typeface="Calibri"/>
               </a:rPr>
-              <a:t>MAC000006: ADF = −9.11, p = 0.000 ✓</a:t>
-            </a:r>
-          </a:p>
-          <a:p>
-            <a:pPr>
-              <a:lnSpc>
-                <a:spcPts val="1300"/>
+              <a:t>Val MASE 0.721 | Test MASE 0.703</a:t>
+            </a:r>
+          </a:p>
+          <a:p>
+            <a:pPr>
+              <a:lnSpc>
+                <a:spcPts val="1300"/>
+              </a:lnSpc>
+            </a:pPr>
+            <a:r>
+              <a:rPr lang="en-US" sz="1400" dirty="0">
+                <a:latin typeface="Calibri"/>
+              </a:rPr>
+              <a:t>Val RMSE 0.225 | Test RMSE 0.221</a:t>
+            </a:r>
+          </a:p>
+          <a:p>
+            <a:pPr>
+              <a:lnSpc>
+                <a:spcPts val="1300"/>
+              </a:lnSpc>
+            </a:pPr>
+            <a:endParaRPr lang="en-US" sz="1400" dirty="0">
+              <a:latin typeface="Calibri"/>
+            </a:endParaRPr>
+          </a:p>
+          <a:p>
+            <a:pPr>
+              <a:lnSpc>
+                <a:spcPts val="1400"/>
               </a:lnSpc>
               <a:spcBef>
-                <a:spcPts val="400"/>
+                <a:spcPts val="500"/>
               </a:spcBef>
             </a:pPr>
             <a:r>
-              <a:rPr lang="en-US" sz="1300" i="1" dirty="0">
+              <a:rPr lang="en-US" sz="1800" b="1" dirty="0">
                 <a:solidFill>
-                  <a:srgbClr val="444444"/>
+                  <a:srgbClr val="1E2761"/>
                 </a:solidFill>
                 <a:latin typeface="Calibri"/>
               </a:rPr>
-              <a:t>No differencing required — series are mean-stationary.</a:t>
-            </a:r>
-          </a:p>
-        </p:txBody>
-      </p:sp>
-      <!-- Divider line -->
-      <p:sp>
-        <p:nvSpPr>
-          <p:cNvPr id="11" name="Divider"/>
-          <p:cNvSpPr>
-            <a:spLocks noGrp="1"/>
-          </p:cNvSpPr>
+              <a:t>Interpretation</a:t>
+            </a:r>
+          </a:p>
+          <a:p>
+            <a:pPr>
+              <a:lnSpc>
+                <a:spcPts val="1300"/>
+              </a:lnSpc>
+              <a:spcBef>
+                <a:spcPts val="200"/>
+              </a:spcBef>
+            </a:pPr>
+            <a:r>
+              <a:rPr lang="en-US" sz="1400" dirty="0">
+                <a:latin typeface="Calibri"/>
+              </a:rPr>
+              <a:t>Global models win slightly in MASE but not in RMSE. Interpreted as a better understanding of general trends but less sensitive to household specific patterns and the model is therefore underfitted to outliers.</a:t>
+            </a:r>
+            <a:endParaRPr lang="en-US" sz="1400" i="1" dirty="0">
+              <a:latin typeface="Calibri"/>
+            </a:endParaRPr>
+          </a:p>
+        </p:txBody>
+      </p:sp>
+      <p:pic>
+        <p:nvPicPr>
+          <p:cNvPr id="7" name="Picture 6">
+            <a:extLst>
+              <a:ext uri="{FF2B5EF4-FFF2-40B4-BE49-F238E27FC236}">
+                <a16:creationId xmlns:a16="http://schemas.microsoft.com/office/drawing/2014/main" id="{BFAE98D6-90DC-1566-8DB5-065E04EAB0DF}"/>
+              </a:ext>
+            </a:extLst>
+          </p:cNvPr>
+          <p:cNvPicPr>
+            <a:picLocks noChangeAspect="1"/>
+          </p:cNvPicPr>
           <p:nvPr/>
-        </p:nvSpPr>
+        </p:nvPicPr>
+        <p:blipFill>
+          <a:blip r:embed="rId2">
+            <a:extLst>
+              <a:ext uri="{28A0092B-C50C-407E-A947-70E740481C1C}">
+                <a14:useLocalDpi xmlns:a14="http://schemas.microsoft.com/office/drawing/2010/main" val="0"/>
+              </a:ext>
+            </a:extLst>
+          </a:blip>
+          <a:stretch>
+            <a:fillRect/>
+          </a:stretch>
+        </p:blipFill>
         <p:spPr>
           <a:xfrm>
-            <a:off x="6096000" y="1200000"/>
-            <a:ext cx="50000" cy="5300000"/>
+            <a:off x="6289771" y="1050000"/>
+            <a:ext cx="4774469" cy="4758266"/>
           </a:xfrm>
           <a:prstGeom prst="rect">
             <a:avLst/>
           </a:prstGeom>
-          <a:solidFill>
-            <a:srgbClr val="CADCFC"/>
-          </a:solidFill>
-          <a:ln>
-            <a:noFill/>
-          </a:ln>
         </p:spPr>
-        <p:txBody>
-          <a:bodyPr/>
-          <a:lstStyle/>
-          <a:p>
-            <a:endParaRPr/>
-          </a:p>
-        </p:txBody>
-      </p:sp>
-      <!-- RIGHT COLUMN: Mann-Kendall Trend -->
-      <p:sp>
-        <p:nvSpPr>
-          <p:cNvPr id="4" name="MKColumn"/>
-          <p:cNvSpPr>
-            <a:spLocks noGrp="1"/>
-          </p:cNvSpPr>
-          <p:nvPr/>
-        </p:nvSpPr>
-        <p:spPr>
-          <a:xfrm>
-            <a:off x="6300000" y="1200000"/>
-            <a:ext cx="5600000" cy="5300000"/>
-          </a:xfrm>
-          <a:prstGeom prst="rect">
-            <a:avLst/>
-          </a:prstGeom>
-          <a:noFill/>
-        </p:spPr>
-        <p:txBody>
-          <a:bodyPr>
-            <a:normAutofit/>
-          </a:bodyPr>
-          <a:lstStyle/>
-          <a:p>
-            <a:pPr>
-              <a:lnSpc>
-                <a:spcPts val="1400"/>
-              </a:lnSpc>
-              <a:spcBef>
-                <a:spcPts val="0"/>
-              </a:spcBef>
-            </a:pPr>
-            <a:r>
-              <a:rPr lang="en-US" sz="1800" b="1" dirty="0">
-                <a:solidFill>
-                  <a:srgbClr val="1E2761"/>
-                </a:solidFill>
-                <a:latin typeface="Calibri"/>
-              </a:rPr>
-              <a:t>Mann-Kendall Trend Test</a:t>
-            </a:r>
-          </a:p>
-          <a:p>
-            <a:pPr>
-              <a:lnSpc>
-                <a:spcPts val="1300"/>
-              </a:lnSpc>
-              <a:spcBef>
-                <a:spcPts val="300"/>
-              </a:spcBef>
-            </a:pPr>
-            <a:r>
-              <a:rPr lang="en-US" sz="1400" dirty="0">
-                <a:latin typeface="Calibri"/>
-              </a:rPr>
-              <a:t xml:space="preserve">MAC000002: </a:t>
-            </a:r>
-            <a:r>
-              <a:rPr lang="en-US" sz="1400" b="1" dirty="0">
-                <a:solidFill>
-                  <a:srgbClr val="C0392B"/>
-                </a:solidFill>
-                <a:latin typeface="Calibri"/>
-              </a:rPr>
-              <a:t>Decreasing trend</a:t>
-            </a:r>
-            <a:r>
-              <a:rPr lang="en-US" sz="1400" dirty="0">
-                <a:latin typeface="Calibri"/>
-              </a:rPr>
-              <a:t xml:space="preserve"> (p=0.000)</a:t>
-            </a:r>
-          </a:p>
-          <a:p>
-            <a:pPr>
-              <a:lnSpc>
-                <a:spcPts val="1300"/>
-              </a:lnSpc>
-            </a:pPr>
-            <a:r>
-              <a:rPr lang="en-US" sz="1400" dirty="0">
-                <a:latin typeface="Calibri"/>
-              </a:rPr>
-              <a:t xml:space="preserve">MAC000003: </a:t>
-            </a:r>
-            <a:r>
-              <a:rPr lang="en-US" sz="1400" b="1" dirty="0">
-                <a:solidFill>
-                  <a:srgbClr val="C0392B"/>
-                </a:solidFill>
-                <a:latin typeface="Calibri"/>
-              </a:rPr>
-              <a:t>Decreasing trend</a:t>
-            </a:r>
-            <a:r>
-              <a:rPr lang="en-US" sz="1400" dirty="0">
-                <a:latin typeface="Calibri"/>
-              </a:rPr>
-              <a:t xml:space="preserve"> (p=0.000)</a:t>
-            </a:r>
-          </a:p>
-          <a:p>
-            <a:pPr>
-              <a:lnSpc>
-                <a:spcPts val="1300"/>
-              </a:lnSpc>
-            </a:pPr>
-            <a:r>
-              <a:rPr lang="en-US" sz="1400" dirty="0">
-                <a:latin typeface="Calibri"/>
-              </a:rPr>
-              <a:t xml:space="preserve">MAC000004: </a:t>
-            </a:r>
-            <a:r>
-              <a:rPr lang="en-US" sz="1400" b="1" dirty="0">
-                <a:solidFill>
-                  <a:srgbClr val="27AE60"/>
-                </a:solidFill>
-                <a:latin typeface="Calibri"/>
-              </a:rPr>
-              <a:t>No trend</a:t>
-            </a:r>
-            <a:r>
-              <a:rPr lang="en-US" sz="1400" dirty="0">
-                <a:latin typeface="Calibri"/>
-              </a:rPr>
-              <a:t xml:space="preserve"> (p=0.876)</a:t>
-            </a:r>
-          </a:p>
-          <a:p>
-            <a:pPr>
-              <a:lnSpc>
-                <a:spcPts val="1300"/>
-              </a:lnSpc>
-            </a:pPr>
-            <a:r>
-              <a:rPr lang="en-US" sz="1400" dirty="0">
-                <a:latin typeface="Calibri"/>
-              </a:rPr>
-              <a:t xml:space="preserve">MAC000005: </a:t>
-            </a:r>
-            <a:r>
-              <a:rPr lang="en-US" sz="1400" b="1" dirty="0">
-                <a:solidFill>
-                  <a:srgbClr val="C0392B"/>
-                </a:solidFill>
-                <a:latin typeface="Calibri"/>
-              </a:rPr>
-              <a:t>Decreasing trend</a:t>
-            </a:r>
-            <a:r>
-              <a:rPr lang="en-US" sz="1400" dirty="0">
-                <a:latin typeface="Calibri"/>
-              </a:rPr>
-              <a:t xml:space="preserve"> (p=0.000)</a:t>
-            </a:r>
-          </a:p>
-          <a:p>
-            <a:pPr>
-              <a:lnSpc>
-                <a:spcPts val="1300"/>
-              </a:lnSpc>
-            </a:pPr>
-            <a:r>
-              <a:rPr lang="en-US" sz="1400" dirty="0">
-                <a:latin typeface="Calibri"/>
-              </a:rPr>
-              <a:t xml:space="preserve">MAC000006: </a:t>
-            </a:r>
-            <a:r>
-              <a:rPr lang="en-US" sz="1400" b="1" dirty="0">
-                <a:solidFill>
-                  <a:srgbClr val="27AE60"/>
-                </a:solidFill>
-                <a:latin typeface="Calibri"/>
-              </a:rPr>
-              <a:t>No trend</a:t>
-            </a:r>
-            <a:r>
-              <a:rPr lang="en-US" sz="1400" dirty="0">
-                <a:latin typeface="Calibri"/>
-              </a:rPr>
-              <a:t xml:space="preserve"> (p=0.341)</a:t>
-            </a:r>
-          </a:p>
-          <a:p>
-            <a:pPr>
-              <a:lnSpc>
-                <a:spcPts val="1300"/>
-              </a:lnSpc>
-              <a:spcBef>
-                <a:spcPts val="400"/>
-              </a:spcBef>
-            </a:pPr>
-            <a:r>
-              <a:rPr lang="en-US" sz="1300" i="1" dirty="0">
-                <a:solidFill>
-                  <a:srgbClr val="444444"/>
-                </a:solidFill>
-                <a:latin typeface="Calibri"/>
-              </a:rPr>
-              <a:t>3 of 5 households show a weak decreasing long-term trend — detrending recommended.</a:t>
-            </a:r>
-          </a:p>
-        </p:txBody>
-      </p:sp>
+      </p:pic>
     </p:spTree>
   </p:cSld>
   <p:clrMapOvr>
@@ -5172,7 +6212,6 @@
           <a:chExt cx="0" cy="0"/>
         </a:xfrm>
       </p:grpSpPr>
-      <!-- Dark header bar -->
       <p:sp>
         <p:nvSpPr>
           <p:cNvPr id="10" name="HeaderBar"/>
@@ -5204,7 +6243,6 @@
           </a:p>
         </p:txBody>
       </p:sp>
-      <!-- Title -->
       <p:sp>
         <p:nvSpPr>
           <p:cNvPr id="2" name="Title"/>
@@ -5232,15 +6270,14 @@
                 </a:solidFill>
                 <a:latin typeface="Calibri"/>
               </a:rPr>
-              <a:t>Task 04 – Diagnostic Summary &amp; Recommendations</a:t>
-            </a:r>
-          </a:p>
-        </p:txBody>
-      </p:sp>
-      <!-- LEFT COLUMN: White test + heteroscedasticity -->
-      <p:sp>
-        <p:nvSpPr>
-          <p:cNvPr id="3" name="WhiteTestColumn"/>
+              <a:t>Task 09 – Global Model with Meta-Features</a:t>
+            </a:r>
+          </a:p>
+        </p:txBody>
+      </p:sp>
+      <p:sp>
+        <p:nvSpPr>
+          <p:cNvPr id="3" name="LeftContent"/>
           <p:cNvSpPr>
             <a:spLocks noGrp="1"/>
           </p:cNvSpPr>
@@ -5249,7 +6286,7 @@
         <p:spPr>
           <a:xfrm>
             <a:off x="457200" y="1200000"/>
-            <a:ext cx="5486400" cy="5300000"/>
+            <a:ext cx="4358640" cy="5200000"/>
           </a:xfrm>
           <a:prstGeom prst="rect">
             <a:avLst/>
@@ -5271,13 +6308,13 @@
               </a:spcBef>
             </a:pPr>
             <a:r>
-              <a:rPr lang="en-US" sz="1800" b="1" dirty="0">
+              <a:rPr lang="en-US" sz="1200" b="1" dirty="0">
                 <a:solidFill>
                   <a:srgbClr val="1E2761"/>
                 </a:solidFill>
                 <a:latin typeface="Calibri"/>
               </a:rPr>
-              <a:t>White Test (Heteroscedasticity)</a:t>
+              <a:t>Motivation</a:t>
             </a:r>
           </a:p>
           <a:p>
@@ -5286,111 +6323,140 @@
                 <a:spcPts val="1300"/>
               </a:lnSpc>
               <a:spcBef>
-                <a:spcPts val="300"/>
+                <a:spcPts val="200"/>
               </a:spcBef>
             </a:pPr>
             <a:r>
-              <a:rPr lang="en-US" sz="1400" dirty="0">
-                <a:latin typeface="Calibri"/>
-              </a:rPr>
-              <a:t xml:space="preserve">MAC000002: LM=20,916, p=0.000 — </a:t>
-            </a:r>
-            <a:r>
-              <a:rPr lang="en-US" sz="1400" b="1" dirty="0">
+              <a:rPr lang="en-US" sz="1050" dirty="0">
+                <a:latin typeface="Calibri"/>
+              </a:rPr>
+              <a:t>The GFM (Task 8) treats all households identically; adding meta-features allows it to specialise by demographic group</a:t>
+            </a:r>
+          </a:p>
+          <a:p>
+            <a:pPr>
+              <a:lnSpc>
+                <a:spcPts val="1300"/>
+              </a:lnSpc>
+            </a:pPr>
+            <a:r>
+              <a:rPr lang="en-US" sz="1050" dirty="0">
+                <a:latin typeface="Calibri"/>
+              </a:rPr>
+              <a:t>Meta-features available: stdorToU (pricing plan), Acorn (20-category), Acorn_grouped (5-category)</a:t>
+            </a:r>
+          </a:p>
+          <a:p>
+            <a:pPr>
+              <a:lnSpc>
+                <a:spcPts val="1300"/>
+              </a:lnSpc>
+            </a:pPr>
+            <a:endParaRPr lang="en-US" sz="1050" dirty="0">
+              <a:latin typeface="Calibri"/>
+            </a:endParaRPr>
+          </a:p>
+          <a:p>
+            <a:pPr>
+              <a:lnSpc>
+                <a:spcPts val="1400"/>
+              </a:lnSpc>
+              <a:spcBef>
+                <a:spcPts val="500"/>
+              </a:spcBef>
+            </a:pPr>
+            <a:r>
+              <a:rPr lang="en-US" sz="1200" b="1" dirty="0">
                 <a:solidFill>
-                  <a:srgbClr val="C0392B"/>
+                  <a:srgbClr val="1E2761"/>
                 </a:solidFill>
                 <a:latin typeface="Calibri"/>
               </a:rPr>
-              <a:t>Heteroskedastic</a:t>
-            </a:r>
-          </a:p>
-          <a:p>
-            <a:pPr>
-              <a:lnSpc>
-                <a:spcPts val="1300"/>
-              </a:lnSpc>
-            </a:pPr>
-            <a:r>
-              <a:rPr lang="en-US" sz="1400" dirty="0">
-                <a:latin typeface="Calibri"/>
-              </a:rPr>
-              <a:t xml:space="preserve">MAC000003: LM=32,059, p=0.000 — </a:t>
-            </a:r>
-            <a:r>
-              <a:rPr lang="en-US" sz="1400" b="1" dirty="0">
+              <a:t>Encoding Variants Tested</a:t>
+            </a:r>
+          </a:p>
+          <a:p>
+            <a:pPr>
+              <a:lnSpc>
+                <a:spcPts val="1300"/>
+              </a:lnSpc>
+              <a:spcBef>
+                <a:spcPts val="200"/>
+              </a:spcBef>
+            </a:pPr>
+            <a:r>
+              <a:rPr lang="en-US" sz="1050" dirty="0">
+                <a:latin typeface="Calibri"/>
+              </a:rPr>
+              <a:t>a_baseline: no meta-features (Task 8 GFM)</a:t>
+            </a:r>
+          </a:p>
+          <a:p>
+            <a:pPr>
+              <a:lnSpc>
+                <a:spcPts val="1300"/>
+              </a:lnSpc>
+            </a:pPr>
+            <a:r>
+              <a:rPr lang="en-US" sz="1050" dirty="0">
+                <a:latin typeface="Calibri"/>
+              </a:rPr>
+              <a:t>b_ohe: one-hot encoding of Acorn_grouped</a:t>
+            </a:r>
+          </a:p>
+          <a:p>
+            <a:pPr>
+              <a:lnSpc>
+                <a:spcPts val="1300"/>
+              </a:lnSpc>
+            </a:pPr>
+            <a:r>
+              <a:rPr lang="en-US" sz="1050" dirty="0">
+                <a:latin typeface="Calibri"/>
+              </a:rPr>
+              <a:t>c_count: count encoding of Acorn (category -&gt; frequency)</a:t>
+            </a:r>
+          </a:p>
+          <a:p>
+            <a:pPr>
+              <a:lnSpc>
+                <a:spcPts val="1300"/>
+              </a:lnSpc>
+            </a:pPr>
+            <a:r>
+              <a:rPr lang="en-US" sz="1050" dirty="0">
+                <a:latin typeface="Calibri"/>
+              </a:rPr>
+              <a:t>d_target_enc: target encoding of Acorn (category -&gt; mean consumption)</a:t>
+            </a:r>
+          </a:p>
+          <a:p>
+            <a:pPr>
+              <a:lnSpc>
+                <a:spcPts val="1300"/>
+              </a:lnSpc>
+            </a:pPr>
+            <a:endParaRPr lang="en-US" sz="1050" dirty="0">
+              <a:latin typeface="Calibri"/>
+            </a:endParaRPr>
+          </a:p>
+          <a:p>
+            <a:pPr>
+              <a:lnSpc>
+                <a:spcPts val="1400"/>
+              </a:lnSpc>
+              <a:spcBef>
+                <a:spcPts val="500"/>
+              </a:spcBef>
+            </a:pPr>
+            <a:r>
+              <a:rPr lang="en-US" sz="1200" b="1" dirty="0">
                 <a:solidFill>
-                  <a:srgbClr val="C0392B"/>
+                  <a:srgbClr val="1E2761"/>
                 </a:solidFill>
                 <a:latin typeface="Calibri"/>
               </a:rPr>
-              <a:t>Heteroskedastic</a:t>
-            </a:r>
-          </a:p>
-          <a:p>
-            <a:pPr>
-              <a:lnSpc>
-                <a:spcPts val="1300"/>
-              </a:lnSpc>
-            </a:pPr>
-            <a:r>
-              <a:rPr lang="en-US" sz="1400" dirty="0">
-                <a:latin typeface="Calibri"/>
-              </a:rPr>
-              <a:t xml:space="preserve">MAC000004: LM=28,532, p=0.000 — </a:t>
-            </a:r>
-            <a:r>
-              <a:rPr lang="en-US" sz="1400" b="1" dirty="0">
-                <a:solidFill>
-                  <a:srgbClr val="C0392B"/>
-                </a:solidFill>
-                <a:latin typeface="Calibri"/>
-              </a:rPr>
-              <a:t>Heteroskedastic</a:t>
-            </a:r>
-          </a:p>
-          <a:p>
-            <a:pPr>
-              <a:lnSpc>
-                <a:spcPts val="1300"/>
-              </a:lnSpc>
-            </a:pPr>
-            <a:r>
-              <a:rPr lang="en-US" sz="1400" dirty="0">
-                <a:latin typeface="Calibri"/>
-              </a:rPr>
-              <a:t xml:space="preserve">MAC000005: LM=27,357, p=0.000 — </a:t>
-            </a:r>
-            <a:r>
-              <a:rPr lang="en-US" sz="1400" b="1" dirty="0">
-                <a:solidFill>
-                  <a:srgbClr val="C0392B"/>
-                </a:solidFill>
-                <a:latin typeface="Calibri"/>
-              </a:rPr>
-              <a:t>Heteroskedastic</a:t>
-            </a:r>
-          </a:p>
-          <a:p>
-            <a:pPr>
-              <a:lnSpc>
-                <a:spcPts val="1300"/>
-              </a:lnSpc>
-            </a:pPr>
-            <a:r>
-              <a:rPr lang="en-US" sz="1400" dirty="0">
-                <a:latin typeface="Calibri"/>
-              </a:rPr>
-              <a:t xml:space="preserve">MAC000006: LM=33,301, p=0.000 — </a:t>
-            </a:r>
-            <a:r>
-              <a:rPr lang="en-US" sz="1400" b="1" dirty="0">
-                <a:solidFill>
-                  <a:srgbClr val="C0392B"/>
-                </a:solidFill>
-                <a:latin typeface="Calibri"/>
-              </a:rPr>
-              <a:t>Heteroskedastic</a:t>
+              <a:t>Results</a:t>
             </a:r>
           </a:p>
           <a:p>
@@ -5399,40 +6465,171 @@
                 <a:spcPts val="1300"/>
               </a:lnSpc>
               <a:spcBef>
-                <a:spcPts val="400"/>
+                <a:spcPts val="200"/>
               </a:spcBef>
             </a:pPr>
             <a:r>
-              <a:rPr lang="en-US" sz="1300" i="1" dirty="0">
-                <a:solidFill>
-                  <a:srgbClr val="444444"/>
-                </a:solidFill>
-                <a:latin typeface="Calibri"/>
-              </a:rPr>
-              <a:t>All households show non-constant variance — log-transform recommended.</a:t>
-            </a:r>
-          </a:p>
-        </p:txBody>
-      </p:sp>
-      <!-- Divider -->
-      <p:sp>
-        <p:nvSpPr>
-          <p:cNvPr id="11" name="Divider"/>
-          <p:cNvSpPr>
-            <a:spLocks noGrp="1"/>
-          </p:cNvSpPr>
+              <a:rPr lang="en-US" sz="1050" b="1" dirty="0" err="1">
+                <a:latin typeface="Calibri"/>
+              </a:rPr>
+              <a:t>Best:One</a:t>
+            </a:r>
+            <a:r>
+              <a:rPr lang="en-US" sz="1050" b="1" dirty="0">
+                <a:latin typeface="Calibri"/>
+              </a:rPr>
+              <a:t> hot encoding</a:t>
+            </a:r>
+          </a:p>
+          <a:p>
+            <a:pPr>
+              <a:lnSpc>
+                <a:spcPts val="1300"/>
+              </a:lnSpc>
+            </a:pPr>
+            <a:r>
+              <a:rPr lang="en-US" sz="1050" dirty="0">
+                <a:latin typeface="Calibri"/>
+              </a:rPr>
+              <a:t>Val MASE: 0.7187 | Test MASE: 0.7013</a:t>
+            </a:r>
+          </a:p>
+          <a:p>
+            <a:pPr>
+              <a:lnSpc>
+                <a:spcPts val="1300"/>
+              </a:lnSpc>
+            </a:pPr>
+            <a:r>
+              <a:rPr lang="en-US" sz="1050" dirty="0">
+                <a:latin typeface="Calibri"/>
+              </a:rPr>
+              <a:t>Marginal improvement over baseline (0.7033 → 0.7013)</a:t>
+            </a:r>
+          </a:p>
+          <a:p>
+            <a:pPr>
+              <a:lnSpc>
+                <a:spcPts val="1300"/>
+              </a:lnSpc>
+            </a:pPr>
+            <a:endParaRPr lang="en-US" sz="1050" dirty="0">
+              <a:latin typeface="Calibri"/>
+            </a:endParaRPr>
+          </a:p>
+          <a:p>
+            <a:pPr>
+              <a:lnSpc>
+                <a:spcPts val="1300"/>
+              </a:lnSpc>
+            </a:pPr>
+            <a:r>
+              <a:rPr lang="en-US" sz="1050" dirty="0">
+                <a:latin typeface="Calibri"/>
+              </a:rPr>
+              <a:t>All encodings perform similarly — meta-features give modest signal.</a:t>
+            </a:r>
+          </a:p>
+          <a:p>
+            <a:pPr>
+              <a:lnSpc>
+                <a:spcPts val="1300"/>
+              </a:lnSpc>
+            </a:pPr>
+            <a:r>
+              <a:rPr lang="en-US" sz="1050" dirty="0">
+                <a:latin typeface="Calibri" panose="020F0502020204030204" pitchFamily="34" charset="0"/>
+                <a:ea typeface="Calibri" panose="020F0502020204030204" pitchFamily="34" charset="0"/>
+                <a:cs typeface="Calibri" panose="020F0502020204030204" pitchFamily="34" charset="0"/>
+              </a:rPr>
+              <a:t>Since there is not a lot of variance between groups (</a:t>
+            </a:r>
+            <a:r>
+              <a:rPr lang="en-US" sz="1050" dirty="0" err="1">
+                <a:latin typeface="Calibri" panose="020F0502020204030204" pitchFamily="34" charset="0"/>
+                <a:ea typeface="Calibri" panose="020F0502020204030204" pitchFamily="34" charset="0"/>
+                <a:cs typeface="Calibri" panose="020F0502020204030204" pitchFamily="34" charset="0"/>
+              </a:rPr>
+              <a:t>Kruskall</a:t>
+            </a:r>
+            <a:r>
+              <a:rPr lang="en-US" sz="1050" dirty="0">
+                <a:latin typeface="Calibri" panose="020F0502020204030204" pitchFamily="34" charset="0"/>
+                <a:ea typeface="Calibri" panose="020F0502020204030204" pitchFamily="34" charset="0"/>
+                <a:cs typeface="Calibri" panose="020F0502020204030204" pitchFamily="34" charset="0"/>
+              </a:rPr>
+              <a:t>-Wallis test) there is no big difference in the encoding of the groups.</a:t>
+            </a:r>
+          </a:p>
+        </p:txBody>
+      </p:sp>
+      <p:pic>
+        <p:nvPicPr>
+          <p:cNvPr id="4" name="EncodingComparisonImg"/>
+          <p:cNvPicPr>
+            <a:picLocks noChangeAspect="1"/>
+          </p:cNvPicPr>
           <p:nvPr/>
-        </p:nvSpPr>
+        </p:nvPicPr>
+        <p:blipFill>
+          <a:blip r:embed="rId2"/>
+          <a:stretch>
+            <a:fillRect/>
+          </a:stretch>
+        </p:blipFill>
         <p:spPr>
           <a:xfrm>
-            <a:off x="6096000" y="1200000"/>
-            <a:ext cx="50000" cy="5300000"/>
+            <a:off x="4495800" y="1499780"/>
+            <a:ext cx="7459980" cy="3900219"/>
+          </a:xfrm>
+          <a:prstGeom prst="rect">
+            <a:avLst/>
+          </a:prstGeom>
+        </p:spPr>
+      </p:pic>
+    </p:spTree>
+  </p:cSld>
+  <p:clrMapOvr>
+    <a:masterClrMapping/>
+  </p:clrMapOvr>
+</p:sld>
+</file>
+
+<file path=ppt/slides/slide9.xml><?xml version="1.0" encoding="utf-8"?>
+<p:sld xmlns:a="http://schemas.openxmlformats.org/drawingml/2006/main" xmlns:r="http://schemas.openxmlformats.org/officeDocument/2006/relationships" xmlns:p="http://schemas.openxmlformats.org/presentationml/2006/main">
+  <p:cSld>
+    <p:spTree>
+      <p:nvGrpSpPr>
+        <p:cNvPr id="1" name=""/>
+        <p:cNvGrpSpPr/>
+        <p:nvPr/>
+      </p:nvGrpSpPr>
+      <p:grpSpPr>
+        <a:xfrm>
+          <a:off x="0" y="0"/>
+          <a:ext cx="0" cy="0"/>
+          <a:chOff x="0" y="0"/>
+          <a:chExt cx="0" cy="0"/>
+        </a:xfrm>
+      </p:grpSpPr>
+      <p:sp>
+        <p:nvSpPr>
+          <p:cNvPr id="10" name="HeaderBar"/>
+          <p:cNvSpPr>
+            <a:spLocks noGrp="1"/>
+          </p:cNvSpPr>
+          <p:nvPr/>
+        </p:nvSpPr>
+        <p:spPr>
+          <a:xfrm>
+            <a:off x="0" y="0"/>
+            <a:ext cx="12192000" cy="1050000"/>
           </a:xfrm>
           <a:prstGeom prst="rect">
             <a:avLst/>
           </a:prstGeom>
           <a:solidFill>
-            <a:srgbClr val="CADCFC"/>
+            <a:srgbClr val="1E2761"/>
           </a:solidFill>
           <a:ln>
             <a:noFill/>
@@ -5446,19 +6643,50 @@
           </a:p>
         </p:txBody>
       </p:sp>
-      <!-- RIGHT COLUMN: Recommended transforms -->
-      <p:sp>
-        <p:nvSpPr>
-          <p:cNvPr id="4" name="RecommendationsColumn"/>
-          <p:cNvSpPr>
-            <a:spLocks noGrp="1"/>
-          </p:cNvSpPr>
-          <p:nvPr/>
+      <p:sp>
+        <p:nvSpPr>
+          <p:cNvPr id="2" name="Title"/>
+          <p:cNvSpPr>
+            <a:spLocks noGrp="1"/>
+          </p:cNvSpPr>
+          <p:nvPr>
+            <p:ph type="title"/>
+          </p:nvPr>
         </p:nvSpPr>
         <p:spPr>
           <a:xfrm>
-            <a:off x="6300000" y="1200000"/>
-            <a:ext cx="5600000" cy="5300000"/>
+            <a:off x="457200" y="100000"/>
+            <a:ext cx="11277600" cy="850000"/>
+          </a:xfrm>
+        </p:spPr>
+        <p:txBody>
+          <a:bodyPr anchor="ctr"/>
+          <a:lstStyle/>
+          <a:p>
+            <a:r>
+              <a:rPr lang="en-US" sz="3200" b="1" dirty="0">
+                <a:solidFill>
+                  <a:srgbClr val="FFFFFF"/>
+                </a:solidFill>
+                <a:latin typeface="Calibri"/>
+              </a:rPr>
+              <a:t>Task 10 – Hyperparameter Tuning</a:t>
+            </a:r>
+          </a:p>
+        </p:txBody>
+      </p:sp>
+      <p:sp>
+        <p:nvSpPr>
+          <p:cNvPr id="3" name="LeftContent"/>
+          <p:cNvSpPr>
+            <a:spLocks noGrp="1"/>
+          </p:cNvSpPr>
+          <p:nvPr/>
+        </p:nvSpPr>
+        <p:spPr>
+          <a:xfrm>
+            <a:off x="457200" y="1200000"/>
+            <a:ext cx="3649980" cy="5200000"/>
           </a:xfrm>
           <a:prstGeom prst="rect">
             <a:avLst/>
@@ -5486,67 +6714,61 @@
                 </a:solidFill>
                 <a:latin typeface="Calibri"/>
               </a:rPr>
-              <a:t>Recommended Transforms</a:t>
-            </a:r>
-          </a:p>
-          <a:p>
-            <a:pPr>
-              <a:lnSpc>
-                <a:spcPts val="1300"/>
+              <a:t>Search Strategies Compared</a:t>
+            </a:r>
+            <a:endParaRPr lang="en-US" b="1" dirty="0">
+              <a:solidFill>
+                <a:srgbClr val="1E2761"/>
+              </a:solidFill>
+              <a:latin typeface="Calibri"/>
+            </a:endParaRPr>
+          </a:p>
+          <a:p>
+            <a:pPr>
+              <a:lnSpc>
+                <a:spcPts val="1400"/>
               </a:lnSpc>
               <a:spcBef>
-                <a:spcPts val="300"/>
+                <a:spcPts val="0"/>
               </a:spcBef>
             </a:pPr>
             <a:r>
-              <a:rPr lang="en-US" sz="1400" b="1" dirty="0">
-                <a:latin typeface="Calibri"/>
-              </a:rPr>
-              <a:t xml:space="preserve">MAC000002 &amp; MAC000003: </a:t>
-            </a:r>
-            <a:r>
               <a:rPr lang="en-US" sz="1400" dirty="0">
                 <a:latin typeface="Calibri"/>
               </a:rPr>
-              <a:t>log-transform, detrend, seasonal features</a:t>
-            </a:r>
-          </a:p>
-          <a:p>
-            <a:pPr>
-              <a:lnSpc>
-                <a:spcPts val="1300"/>
-              </a:lnSpc>
-            </a:pPr>
-            <a:r>
-              <a:rPr lang="en-US" sz="1400" b="1" dirty="0">
-                <a:latin typeface="Calibri"/>
-              </a:rPr>
-              <a:t xml:space="preserve">MAC000004: </a:t>
-            </a:r>
+              <a:t>Tuning summary</a:t>
+            </a:r>
+          </a:p>
+          <a:p>
+            <a:pPr>
+              <a:lnSpc>
+                <a:spcPts val="1400"/>
+              </a:lnSpc>
+              <a:spcBef>
+                <a:spcPts val="0"/>
+              </a:spcBef>
+            </a:pPr>
             <a:r>
               <a:rPr lang="en-US" sz="1400" dirty="0">
                 <a:latin typeface="Calibri"/>
               </a:rPr>
-              <a:t>log-transform only</a:t>
-            </a:r>
-          </a:p>
-          <a:p>
-            <a:pPr>
-              <a:lnSpc>
-                <a:spcPts val="1300"/>
-              </a:lnSpc>
-            </a:pPr>
-            <a:r>
-              <a:rPr lang="en-US" sz="1400" b="1" dirty="0">
-                <a:latin typeface="Calibri"/>
-              </a:rPr>
-              <a:t xml:space="preserve">MAC000005 &amp; MAC000006: </a:t>
-            </a:r>
+              <a:t>=================================</a:t>
+            </a:r>
+          </a:p>
+          <a:p>
+            <a:pPr>
+              <a:lnSpc>
+                <a:spcPts val="1400"/>
+              </a:lnSpc>
+              <a:spcBef>
+                <a:spcPts val="0"/>
+              </a:spcBef>
+            </a:pPr>
             <a:r>
               <a:rPr lang="en-US" sz="1400" dirty="0">
                 <a:latin typeface="Calibri"/>
               </a:rPr>
-              <a:t>log-transform, seasonal features</a:t>
+              <a:t>Strategy	configs	Val MASE	Wall time</a:t>
             </a:r>
           </a:p>
           <a:p>
@@ -5555,37 +6777,86 @@
                 <a:spcPts val="1400"/>
               </a:lnSpc>
               <a:spcBef>
-                <a:spcPts val="500"/>
+                <a:spcPts val="0"/>
               </a:spcBef>
             </a:pPr>
             <a:r>
-              <a:rPr lang="en-US" sz="1800" b="1" dirty="0">
-                <a:solidFill>
-                  <a:srgbClr val="1E2761"/>
-                </a:solidFill>
-                <a:latin typeface="Calibri"/>
-              </a:rPr>
-              <a:t>Overall Conclusion</a:t>
-            </a:r>
-          </a:p>
-          <a:p>
-            <a:pPr>
-              <a:lnSpc>
-                <a:spcPts val="1300"/>
+              <a:rPr lang="en-US" sz="1400" dirty="0">
+                <a:latin typeface="Calibri"/>
+              </a:rPr>
+              <a:t>Grid	27	0.5887	101.3s</a:t>
+            </a:r>
+          </a:p>
+          <a:p>
+            <a:pPr>
+              <a:lnSpc>
+                <a:spcPts val="1400"/>
               </a:lnSpc>
               <a:spcBef>
-                <a:spcPts val="300"/>
+                <a:spcPts val="0"/>
               </a:spcBef>
             </a:pPr>
             <a:r>
               <a:rPr lang="en-US" sz="1400" dirty="0">
                 <a:latin typeface="Calibri"/>
               </a:rPr>
-              <a:t>Series are stationary but heteroscedastic with seasonal structure. Log-transform stabilises variance; seasonal features and detrending improve model fit for trending households.</a:t>
-            </a:r>
-          </a:p>
-        </p:txBody>
-      </p:sp>
+              <a:t>Random	5	0.5852    	21.3s</a:t>
+            </a:r>
+          </a:p>
+          <a:p>
+            <a:pPr>
+              <a:lnSpc>
+                <a:spcPts val="1400"/>
+              </a:lnSpc>
+              <a:spcBef>
+                <a:spcPts val="0"/>
+              </a:spcBef>
+            </a:pPr>
+            <a:r>
+              <a:rPr lang="en-US" sz="1400" dirty="0">
+                <a:latin typeface="Calibri"/>
+              </a:rPr>
+              <a:t>Bayesian	5	0.5808    	23.0s</a:t>
+            </a:r>
+          </a:p>
+        </p:txBody>
+      </p:sp>
+      <p:pic>
+        <p:nvPicPr>
+          <p:cNvPr id="7" name="Picture 6">
+            <a:extLst>
+              <a:ext uri="{FF2B5EF4-FFF2-40B4-BE49-F238E27FC236}">
+                <a16:creationId xmlns:a16="http://schemas.microsoft.com/office/drawing/2014/main" id="{411398BE-48B0-D885-9414-CACB055974A9}"/>
+              </a:ext>
+            </a:extLst>
+          </p:cNvPr>
+          <p:cNvPicPr>
+            <a:picLocks noChangeAspect="1"/>
+          </p:cNvPicPr>
+          <p:nvPr/>
+        </p:nvPicPr>
+        <p:blipFill>
+          <a:blip r:embed="rId2">
+            <a:extLst>
+              <a:ext uri="{28A0092B-C50C-407E-A947-70E740481C1C}">
+                <a14:useLocalDpi xmlns:a14="http://schemas.microsoft.com/office/drawing/2010/main" val="0"/>
+              </a:ext>
+            </a:extLst>
+          </a:blip>
+          <a:stretch>
+            <a:fillRect/>
+          </a:stretch>
+        </p:blipFill>
+        <p:spPr>
+          <a:xfrm>
+            <a:off x="4107179" y="1345840"/>
+            <a:ext cx="7682619" cy="4399639"/>
+          </a:xfrm>
+          <a:prstGeom prst="rect">
+            <a:avLst/>
+          </a:prstGeom>
+        </p:spPr>
+      </p:pic>
     </p:spTree>
   </p:cSld>
   <p:clrMapOvr>
@@ -5920,41 +7191,41 @@
 </file>
 
 <file path=customXml/item1.xml><?xml version="1.0" encoding="utf-8"?>
+<TemplafySlideFormConfiguration><![CDATA[{"formFields":[],"formDataEntries":[]}]]></TemplafySlideFormConfiguration>
+</file>
+
+<file path=customXml/item2.xml><?xml version="1.0" encoding="utf-8"?>
 <TemplafySlideTemplateConfiguration><![CDATA[{"slideVersion":1,"isValidatorEnabled":false,"isLocked":false,"elementsMetadata":[],"slideId":"1054884848216047618","enableDocumentContentUpdater":false,"version":"2.0"}]]></TemplafySlideTemplateConfiguration>
 </file>
 
-<file path=customXml/item2.xml><?xml version="1.0" encoding="utf-8"?>
-<TemplafySlideFormConfiguration><![CDATA[{"formFields":[],"formDataEntries":[]}]]></TemplafySlideFormConfiguration>
+<file path=customXml/item3.xml><?xml version="1.0" encoding="utf-8"?>
+<TemplafyTemplateConfiguration><![CDATA[{"elementsMetadata":[],"transformationConfigurations":[],"templateName":"blankpresentation","templateDescription":"","enableDocumentContentUpdater":false,"version":"2.0"}]]></TemplafyTemplateConfiguration>
 </file>
 
-<file path=customXml/item3.xml><?xml version="1.0" encoding="utf-8"?>
+<file path=customXml/item4.xml><?xml version="1.0" encoding="utf-8"?>
 <TemplafyFormConfiguration><![CDATA[{"formFields":[],"formDataEntries":[]}]]></TemplafyFormConfiguration>
 </file>
 
-<file path=customXml/item4.xml><?xml version="1.0" encoding="utf-8"?>
-<TemplafyTemplateConfiguration><![CDATA[{"elementsMetadata":[],"transformationConfigurations":[],"templateName":"blankpresentation","templateDescription":"","enableDocumentContentUpdater":false,"version":"2.0"}]]></TemplafyTemplateConfiguration>
+<file path=customXml/itemProps1.xml><?xml version="1.0" encoding="utf-8"?>
+<ds:datastoreItem xmlns:ds="http://schemas.openxmlformats.org/officeDocument/2006/customXml" ds:itemID="{C60B9EDF-596D-4F67-B5E3-411D55B8E8FC}">
+  <ds:schemaRefs/>
+</ds:datastoreItem>
 </file>
 
-<file path=customXml/itemProps1.xml><?xml version="1.0" encoding="utf-8"?>
+<file path=customXml/itemProps2.xml><?xml version="1.0" encoding="utf-8"?>
 <ds:datastoreItem xmlns:ds="http://schemas.openxmlformats.org/officeDocument/2006/customXml" ds:itemID="{B69ABF3A-B169-44F9-86AC-4E29FB2A2600}">
   <ds:schemaRefs/>
 </ds:datastoreItem>
 </file>
 
-<file path=customXml/itemProps2.xml><?xml version="1.0" encoding="utf-8"?>
-<ds:datastoreItem xmlns:ds="http://schemas.openxmlformats.org/officeDocument/2006/customXml" ds:itemID="{C60B9EDF-596D-4F67-B5E3-411D55B8E8FC}">
-  <ds:schemaRefs/>
-</ds:datastoreItem>
-</file>
-
 <file path=customXml/itemProps3.xml><?xml version="1.0" encoding="utf-8"?>
-<ds:datastoreItem xmlns:ds="http://schemas.openxmlformats.org/officeDocument/2006/customXml" ds:itemID="{C5938109-F486-41EA-929F-D7DF65C5D6B1}">
+<ds:datastoreItem xmlns:ds="http://schemas.openxmlformats.org/officeDocument/2006/customXml" ds:itemID="{386C9AF7-FC43-4772-BF6D-26FE95C56D62}">
   <ds:schemaRefs/>
 </ds:datastoreItem>
 </file>
 
 <file path=customXml/itemProps4.xml><?xml version="1.0" encoding="utf-8"?>
-<ds:datastoreItem xmlns:ds="http://schemas.openxmlformats.org/officeDocument/2006/customXml" ds:itemID="{386C9AF7-FC43-4772-BF6D-26FE95C56D62}">
+<ds:datastoreItem xmlns:ds="http://schemas.openxmlformats.org/officeDocument/2006/customXml" ds:itemID="{C5938109-F486-41EA-929F-D7DF65C5D6B1}">
   <ds:schemaRefs/>
 </ds:datastoreItem>
 </file>
</xml_diff>

<commit_message>
Finished multiple seed runs of FD001 and FD002
</commit_message>
<xml_diff>
--- a/Deep learning for time-series/Assignment 2/Presentation.pptx
+++ b/Deep learning for time-series/Assignment 2/Presentation.pptx
@@ -213,7 +213,7 @@
           <a:p>
             <a:fld id="{D4FF3FCA-946D-4CC5-B026-9510E72B2D19}" type="datetimeFigureOut">
               <a:rPr lang="da-DK" smtClean="0"/>
-              <a:t>27-04-2026</a:t>
+              <a:t>01-05-2026</a:t>
             </a:fld>
             <a:endParaRPr lang="da-DK"/>
           </a:p>
@@ -711,7 +711,7 @@
           <a:p>
             <a:fld id="{1A886069-5185-423F-843D-C2F3A033B902}" type="datetimeFigureOut">
               <a:rPr lang="en-US" smtClean="0"/>
-              <a:t>4/27/2026</a:t>
+              <a:t>5/1/2026</a:t>
             </a:fld>
             <a:endParaRPr lang="en-US"/>
           </a:p>
@@ -910,7 +910,7 @@
           <a:p>
             <a:fld id="{1A886069-5185-423F-843D-C2F3A033B902}" type="datetimeFigureOut">
               <a:rPr lang="en-US" smtClean="0"/>
-              <a:t>4/27/2026</a:t>
+              <a:t>5/1/2026</a:t>
             </a:fld>
             <a:endParaRPr lang="en-US"/>
           </a:p>
@@ -1119,7 +1119,7 @@
           <a:p>
             <a:fld id="{1A886069-5185-423F-843D-C2F3A033B902}" type="datetimeFigureOut">
               <a:rPr lang="en-US" smtClean="0"/>
-              <a:t>4/27/2026</a:t>
+              <a:t>5/1/2026</a:t>
             </a:fld>
             <a:endParaRPr lang="en-US"/>
           </a:p>
@@ -1318,7 +1318,7 @@
           <a:p>
             <a:fld id="{1A886069-5185-423F-843D-C2F3A033B902}" type="datetimeFigureOut">
               <a:rPr lang="en-US" smtClean="0"/>
-              <a:t>4/27/2026</a:t>
+              <a:t>5/1/2026</a:t>
             </a:fld>
             <a:endParaRPr lang="en-US"/>
           </a:p>
@@ -1594,7 +1594,7 @@
           <a:p>
             <a:fld id="{1A886069-5185-423F-843D-C2F3A033B902}" type="datetimeFigureOut">
               <a:rPr lang="en-US" smtClean="0"/>
-              <a:t>4/27/2026</a:t>
+              <a:t>5/1/2026</a:t>
             </a:fld>
             <a:endParaRPr lang="en-US"/>
           </a:p>
@@ -1860,7 +1860,7 @@
           <a:p>
             <a:fld id="{1A886069-5185-423F-843D-C2F3A033B902}" type="datetimeFigureOut">
               <a:rPr lang="en-US" smtClean="0"/>
-              <a:t>4/27/2026</a:t>
+              <a:t>5/1/2026</a:t>
             </a:fld>
             <a:endParaRPr lang="en-US"/>
           </a:p>
@@ -2273,7 +2273,7 @@
           <a:p>
             <a:fld id="{1A886069-5185-423F-843D-C2F3A033B902}" type="datetimeFigureOut">
               <a:rPr lang="en-US" smtClean="0"/>
-              <a:t>4/27/2026</a:t>
+              <a:t>5/1/2026</a:t>
             </a:fld>
             <a:endParaRPr lang="en-US"/>
           </a:p>
@@ -2415,7 +2415,7 @@
           <a:p>
             <a:fld id="{1A886069-5185-423F-843D-C2F3A033B902}" type="datetimeFigureOut">
               <a:rPr lang="en-US" smtClean="0"/>
-              <a:t>4/27/2026</a:t>
+              <a:t>5/1/2026</a:t>
             </a:fld>
             <a:endParaRPr lang="en-US"/>
           </a:p>
@@ -2529,7 +2529,7 @@
           <a:p>
             <a:fld id="{1A886069-5185-423F-843D-C2F3A033B902}" type="datetimeFigureOut">
               <a:rPr lang="en-US" smtClean="0"/>
-              <a:t>4/27/2026</a:t>
+              <a:t>5/1/2026</a:t>
             </a:fld>
             <a:endParaRPr lang="en-US"/>
           </a:p>
@@ -2841,7 +2841,7 @@
           <a:p>
             <a:fld id="{1A886069-5185-423F-843D-C2F3A033B902}" type="datetimeFigureOut">
               <a:rPr lang="en-US" smtClean="0"/>
-              <a:t>4/27/2026</a:t>
+              <a:t>5/1/2026</a:t>
             </a:fld>
             <a:endParaRPr lang="en-US"/>
           </a:p>
@@ -3130,7 +3130,7 @@
           <a:p>
             <a:fld id="{1A886069-5185-423F-843D-C2F3A033B902}" type="datetimeFigureOut">
               <a:rPr lang="en-US" smtClean="0"/>
-              <a:t>4/27/2026</a:t>
+              <a:t>5/1/2026</a:t>
             </a:fld>
             <a:endParaRPr lang="en-US"/>
           </a:p>
@@ -3372,7 +3372,7 @@
           <a:p>
             <a:fld id="{1A886069-5185-423F-843D-C2F3A033B902}" type="datetimeFigureOut">
               <a:rPr lang="en-US" smtClean="0"/>
-              <a:t>4/27/2026</a:t>
+              <a:t>5/1/2026</a:t>
             </a:fld>
             <a:endParaRPr lang="en-US"/>
           </a:p>
@@ -4904,7 +4904,7 @@
               <a:rPr lang="en-US" sz="1400" dirty="0">
                 <a:latin typeface="Calibri"/>
               </a:rPr>
-              <a:t>Seasonal (48 slots) mean preserves the daily pattern, plateau introduced by forward-fill.</a:t>
+              <a:t>Seasonal (48 slots) mean preserves the daily pattern; plateau would be introduced by forward-fill.</a:t>
             </a:r>
             <a:br>
               <a:rPr lang="en-US" sz="1400" dirty="0">
@@ -6080,7 +6080,7 @@
               <a:rPr lang="en-US" sz="1200" dirty="0">
                 <a:latin typeface="Calibri"/>
               </a:rPr>
-              <a:t>Transform: Log-</a:t>
+              <a:t>Transform: Log + </a:t>
             </a:r>
             <a:r>
               <a:rPr lang="en-US" sz="1200" dirty="0" err="1">
@@ -6389,7 +6389,19 @@
               <a:rPr lang="en-US" sz="1100" dirty="0">
                 <a:latin typeface="Calibri"/>
               </a:rPr>
-              <a:t>Same LightGBM + log-deseasonalising pipeline applied to the full cohort (50 households)</a:t>
+              <a:t>Same LightGBM + log-</a:t>
+            </a:r>
+            <a:r>
+              <a:rPr lang="en-US" sz="1100" dirty="0" err="1">
+                <a:latin typeface="Calibri"/>
+              </a:rPr>
+              <a:t>deseasonalising</a:t>
+            </a:r>
+            <a:r>
+              <a:rPr lang="en-US" sz="1100" dirty="0">
+                <a:latin typeface="Calibri"/>
+              </a:rPr>
+              <a:t> pipeline applied to the full cohort (50 households)</a:t>
             </a:r>
           </a:p>
           <a:p>
@@ -8280,7 +8292,7 @@
 </file>
 
 <file path=customXml/item2.xml><?xml version="1.0" encoding="utf-8"?>
-<TemplafySlideFormConfiguration><![CDATA[{"formFields":[],"formDataEntries":[]}]]></TemplafySlideFormConfiguration>
+<TemplafyTemplateConfiguration><![CDATA[{"elementsMetadata":[],"transformationConfigurations":[],"templateName":"blankpresentation","templateDescription":"","enableDocumentContentUpdater":false,"version":"2.0"}]]></TemplafyTemplateConfiguration>
 </file>
 
 <file path=customXml/item3.xml><?xml version="1.0" encoding="utf-8"?>
@@ -8288,7 +8300,7 @@
 </file>
 
 <file path=customXml/item4.xml><?xml version="1.0" encoding="utf-8"?>
-<TemplafyTemplateConfiguration><![CDATA[{"elementsMetadata":[],"transformationConfigurations":[],"templateName":"blankpresentation","templateDescription":"","enableDocumentContentUpdater":false,"version":"2.0"}]]></TemplafyTemplateConfiguration>
+<TemplafySlideFormConfiguration><![CDATA[{"formFields":[],"formDataEntries":[]}]]></TemplafySlideFormConfiguration>
 </file>
 
 <file path=customXml/itemProps1.xml><?xml version="1.0" encoding="utf-8"?>
@@ -8298,7 +8310,7 @@
 </file>
 
 <file path=customXml/itemProps2.xml><?xml version="1.0" encoding="utf-8"?>
-<ds:datastoreItem xmlns:ds="http://schemas.openxmlformats.org/officeDocument/2006/customXml" ds:itemID="{C60B9EDF-596D-4F67-B5E3-411D55B8E8FC}">
+<ds:datastoreItem xmlns:ds="http://schemas.openxmlformats.org/officeDocument/2006/customXml" ds:itemID="{386C9AF7-FC43-4772-BF6D-26FE95C56D62}">
   <ds:schemaRefs/>
 </ds:datastoreItem>
 </file>
@@ -8310,7 +8322,7 @@
 </file>
 
 <file path=customXml/itemProps4.xml><?xml version="1.0" encoding="utf-8"?>
-<ds:datastoreItem xmlns:ds="http://schemas.openxmlformats.org/officeDocument/2006/customXml" ds:itemID="{386C9AF7-FC43-4772-BF6D-26FE95C56D62}">
+<ds:datastoreItem xmlns:ds="http://schemas.openxmlformats.org/officeDocument/2006/customXml" ds:itemID="{C60B9EDF-596D-4F67-B5E3-411D55B8E8FC}">
   <ds:schemaRefs/>
 </ds:datastoreItem>
 </file>
</xml_diff>